<commit_message>
docs: update rent map and api description
</commit_message>
<xml_diff>
--- a/docs/Housing-API.pptx
+++ b/docs/Housing-API.pptx
@@ -16,13 +16,14 @@
     <p:sldId id="260" r:id="rId9"/>
     <p:sldId id="268" r:id="rId10"/>
     <p:sldId id="269" r:id="rId11"/>
-    <p:sldId id="261" r:id="rId12"/>
-    <p:sldId id="264" r:id="rId13"/>
-    <p:sldId id="265" r:id="rId14"/>
-    <p:sldId id="266" r:id="rId15"/>
-    <p:sldId id="267" r:id="rId16"/>
-    <p:sldId id="262" r:id="rId17"/>
-    <p:sldId id="263" r:id="rId18"/>
+    <p:sldId id="270" r:id="rId12"/>
+    <p:sldId id="261" r:id="rId13"/>
+    <p:sldId id="264" r:id="rId14"/>
+    <p:sldId id="265" r:id="rId15"/>
+    <p:sldId id="266" r:id="rId16"/>
+    <p:sldId id="267" r:id="rId17"/>
+    <p:sldId id="262" r:id="rId18"/>
+    <p:sldId id="263" r:id="rId19"/>
   </p:sldIdLst>
   <p:sldSz cx="9144000" cy="5143500"/>
   <p:notesSz cx="5143500" cy="9144000"/>
@@ -859,6 +860,84 @@
 </file>
 
 <file path=ppt/notesSlides/notesSlide14.xml><?xml version="1.0" encoding="utf-8"?>
+<p:notes xmlns:a="http://schemas.openxmlformats.org/drawingml/2006/main" xmlns:r="http://schemas.openxmlformats.org/officeDocument/2006/relationships" xmlns:p="http://schemas.openxmlformats.org/presentationml/2006/main">
+  <p:cSld>
+    <p:spTree>
+      <p:nvGrpSpPr>
+        <p:cNvPr id="1" name=""/>
+        <p:cNvGrpSpPr/>
+        <p:nvPr/>
+      </p:nvGrpSpPr>
+      <p:grpSpPr>
+        <a:xfrm>
+          <a:off x="0" y="0"/>
+          <a:ext cx="0" cy="0"/>
+          <a:chOff x="0" y="0"/>
+          <a:chExt cx="0" cy="0"/>
+        </a:xfrm>
+      </p:grpSpPr>
+      <p:sp>
+        <p:nvSpPr>
+          <p:cNvPr id="2" name="Slide Image Placeholder 1"/>
+          <p:cNvSpPr>
+            <a:spLocks noGrp="1" noRot="1" noChangeAspect="1"/>
+          </p:cNvSpPr>
+          <p:nvPr>
+            <p:ph type="sldImg"/>
+          </p:nvPr>
+        </p:nvSpPr>
+        <p:spPr/>
+      </p:sp>
+      <p:sp>
+        <p:nvSpPr>
+          <p:cNvPr id="3" name="Notes Placeholder 2"/>
+          <p:cNvSpPr>
+            <a:spLocks noGrp="1"/>
+          </p:cNvSpPr>
+          <p:nvPr>
+            <p:ph type="body" idx="1"/>
+          </p:nvPr>
+        </p:nvSpPr>
+        <p:spPr/>
+        <p:txBody>
+          <a:bodyPr/>
+          <a:lstStyle/>
+          <a:p>
+            <a:endParaRPr lang="en-US" dirty="0"/>
+          </a:p>
+        </p:txBody>
+      </p:sp>
+      <p:sp>
+        <p:nvSpPr>
+          <p:cNvPr id="4" name="Slide Number Placeholder 3"/>
+          <p:cNvSpPr>
+            <a:spLocks noGrp="1"/>
+          </p:cNvSpPr>
+          <p:nvPr>
+            <p:ph type="sldNum" sz="quarter" idx="10"/>
+          </p:nvPr>
+        </p:nvSpPr>
+        <p:spPr/>
+        <p:txBody>
+          <a:bodyPr/>
+          <a:lstStyle/>
+          <a:p>
+            <a:fld id="{F7021451-1387-4CA6-816F-3879F97B5CBC}" type="slidenum">
+              <a:rPr lang="en-US"/>
+            </a:fld>
+            <a:endParaRPr lang="en-US"/>
+          </a:p>
+        </p:txBody>
+      </p:sp>
+    </p:spTree>
+  </p:cSld>
+  <p:clrMapOvr>
+    <a:masterClrMapping/>
+  </p:clrMapOvr>
+</p:notes>
+</file>
+
+<file path=ppt/notesSlides/notesSlide15.xml><?xml version="1.0" encoding="utf-8"?>
 <p:notes xmlns:a="http://schemas.openxmlformats.org/drawingml/2006/main" xmlns:r="http://schemas.openxmlformats.org/officeDocument/2006/relationships" xmlns:p="http://schemas.openxmlformats.org/presentationml/2006/main">
   <p:cSld>
     <p:spTree>
@@ -2653,7 +2732,7 @@
                 <a:latin typeface="微软雅黑" panose="020B0503020204020204" charset="-122"/>
                 <a:ea typeface="微软雅黑" panose="020B0503020204020204" charset="-122"/>
               </a:rPr>
-              <a:t>API Documentation Overview</a:t>
+              <a:t>Version Control Practices and Commit History</a:t>
             </a:r>
             <a:endParaRPr lang="en-US" altLang="zh-CN" sz="1780" b="1" dirty="0">
               <a:latin typeface="微软雅黑" panose="020B0503020204020204" charset="-122"/>
@@ -2800,7 +2879,7 @@
         <p:spPr>
           <a:xfrm>
             <a:off x="190500" y="790575"/>
-            <a:ext cx="8290560" cy="829945"/>
+            <a:ext cx="8290560" cy="1076325"/>
           </a:xfrm>
           <a:prstGeom prst="rect">
             <a:avLst/>
@@ -2818,7 +2897,7 @@
             </a:pPr>
             <a:r>
               <a:rPr lang="en-US" altLang="zh-CN" sz="1600"/>
-              <a:t>FastAPI auto-generated OpenAPI / Swagger documentation</a:t>
+              <a:t>Public GitHub repository used throughout development.</a:t>
             </a:r>
             <a:endParaRPr lang="en-US" altLang="zh-CN" sz="1600"/>
           </a:p>
@@ -2829,7 +2908,7 @@
             </a:pPr>
             <a:r>
               <a:rPr lang="en-US" altLang="zh-CN" sz="1600"/>
-              <a:t>documents routes, request models, responses, authentication flows</a:t>
+              <a:t>Incremental commits documented database setup, API implementation, testing, and deployment changes.</a:t>
             </a:r>
             <a:endParaRPr lang="en-US" altLang="zh-CN" sz="1600"/>
           </a:p>
@@ -2840,7 +2919,7 @@
             </a:pPr>
             <a:r>
               <a:rPr lang="en-US" altLang="zh-CN" sz="1600"/>
-              <a:t>reduces drift between implementation and documentation</a:t>
+              <a:t>Commit history reflects staged development rather than one-time upload.</a:t>
             </a:r>
             <a:endParaRPr lang="en-US" altLang="zh-CN" sz="1600"/>
           </a:p>
@@ -2848,7 +2927,7 @@
       </p:sp>
       <p:pic>
         <p:nvPicPr>
-          <p:cNvPr id="8" name="图片 7"/>
+          <p:cNvPr id="23" name="图片 22"/>
           <p:cNvPicPr>
             <a:picLocks noChangeAspect="1"/>
           </p:cNvPicPr>
@@ -2862,8 +2941,8 @@
         </p:blipFill>
         <p:spPr>
           <a:xfrm>
-            <a:off x="186055" y="1662430"/>
-            <a:ext cx="4166870" cy="3041650"/>
+            <a:off x="659130" y="1971675"/>
+            <a:ext cx="2999740" cy="2729865"/>
           </a:xfrm>
           <a:prstGeom prst="rect">
             <a:avLst/>
@@ -2872,7 +2951,7 @@
       </p:pic>
       <p:pic>
         <p:nvPicPr>
-          <p:cNvPr id="9" name="图片 8"/>
+          <p:cNvPr id="25" name="图片 24"/>
           <p:cNvPicPr>
             <a:picLocks noChangeAspect="1"/>
           </p:cNvPicPr>
@@ -2886,8 +2965,8 @@
         </p:blipFill>
         <p:spPr>
           <a:xfrm>
-            <a:off x="4852035" y="1662430"/>
-            <a:ext cx="3901440" cy="3041015"/>
+            <a:off x="5035550" y="1971675"/>
+            <a:ext cx="3445510" cy="2173605"/>
           </a:xfrm>
           <a:prstGeom prst="rect">
             <a:avLst/>
@@ -3004,7 +3083,7 @@
                 <a:latin typeface="微软雅黑" panose="020B0503020204020204" charset="-122"/>
                 <a:ea typeface="微软雅黑" panose="020B0503020204020204" charset="-122"/>
               </a:rPr>
-              <a:t>Technical Report Highlights</a:t>
+              <a:t>API Documentation Overview</a:t>
             </a:r>
             <a:endParaRPr lang="en-US" altLang="zh-CN" sz="1780" b="1" dirty="0">
               <a:latin typeface="微软雅黑" panose="020B0503020204020204" charset="-122"/>
@@ -3150,8 +3229,8 @@
         </p:nvSpPr>
         <p:spPr>
           <a:xfrm>
-            <a:off x="1527810" y="1436370"/>
-            <a:ext cx="5996305" cy="2799715"/>
+            <a:off x="190500" y="790575"/>
+            <a:ext cx="8290560" cy="829945"/>
           </a:xfrm>
           <a:prstGeom prst="rect">
             <a:avLst/>
@@ -3169,7 +3248,7 @@
             </a:pPr>
             <a:r>
               <a:rPr lang="en-US" altLang="zh-CN" sz="1600"/>
-              <a:t>Architecture: layered FastAPI design with routers, services, and database separation</a:t>
+              <a:t>FastAPI auto-generated OpenAPI / Swagger documentation</a:t>
             </a:r>
             <a:endParaRPr lang="en-US" altLang="zh-CN" sz="1600"/>
           </a:p>
@@ -3178,6 +3257,10 @@
               <a:buFont typeface="Wingdings" panose="05000000000000000000" charset="0"/>
               <a:buChar char="l"/>
             </a:pPr>
+            <a:r>
+              <a:rPr lang="en-US" altLang="zh-CN" sz="1600"/>
+              <a:t>documents routes, request models, responses, authentication flows</a:t>
+            </a:r>
             <a:endParaRPr lang="en-US" altLang="zh-CN" sz="1600"/>
           </a:p>
           <a:p>
@@ -3187,48 +3270,60 @@
             </a:pPr>
             <a:r>
               <a:rPr lang="en-US" altLang="zh-CN" sz="1600"/>
-              <a:t>Design choice: official datasets separated from user-managed editable records</a:t>
+              <a:t>reduces drift between implementation and documentation</a:t>
             </a:r>
             <a:endParaRPr lang="en-US" altLang="zh-CN" sz="1600"/>
           </a:p>
-          <a:p>
-            <a:pPr marL="285750" indent="-285750">
-              <a:buFont typeface="Wingdings" panose="05000000000000000000" charset="0"/>
-              <a:buChar char="l"/>
-            </a:pPr>
-            <a:endParaRPr lang="en-US" altLang="zh-CN" sz="1600"/>
-          </a:p>
-          <a:p>
-            <a:pPr marL="285750" indent="-285750">
-              <a:buFont typeface="Wingdings" panose="05000000000000000000" charset="0"/>
-              <a:buChar char="l"/>
-            </a:pPr>
-            <a:r>
-              <a:rPr lang="en-US" altLang="zh-CN" sz="1600"/>
-              <a:t>Technology stack: FastAPI + SQLite chosen for portability, schema-first design, and coursework practicality</a:t>
-            </a:r>
-            <a:endParaRPr lang="en-US" altLang="zh-CN" sz="1600"/>
-          </a:p>
-          <a:p>
-            <a:pPr marL="285750" indent="-285750">
-              <a:buFont typeface="Wingdings" panose="05000000000000000000" charset="0"/>
-              <a:buChar char="l"/>
-            </a:pPr>
-            <a:endParaRPr lang="en-US" altLang="zh-CN" sz="1600"/>
-          </a:p>
-          <a:p>
-            <a:pPr marL="285750" indent="-285750">
-              <a:buFont typeface="Wingdings" panose="05000000000000000000" charset="0"/>
-              <a:buChar char="l"/>
-            </a:pPr>
-            <a:r>
-              <a:rPr lang="en-US" altLang="zh-CN" sz="1600"/>
-              <a:t>Lessons learned: testing improved not just correctness, but API contract clarity</a:t>
-            </a:r>
-            <a:endParaRPr lang="en-US" altLang="zh-CN" sz="1600"/>
-          </a:p>
-        </p:txBody>
-      </p:sp>
+        </p:txBody>
+      </p:sp>
+      <p:pic>
+        <p:nvPicPr>
+          <p:cNvPr id="8" name="图片 7"/>
+          <p:cNvPicPr>
+            <a:picLocks noChangeAspect="1"/>
+          </p:cNvPicPr>
+          <p:nvPr/>
+        </p:nvPicPr>
+        <p:blipFill>
+          <a:blip r:embed="rId1"/>
+          <a:stretch>
+            <a:fillRect/>
+          </a:stretch>
+        </p:blipFill>
+        <p:spPr>
+          <a:xfrm>
+            <a:off x="186055" y="1662430"/>
+            <a:ext cx="4166870" cy="3041650"/>
+          </a:xfrm>
+          <a:prstGeom prst="rect">
+            <a:avLst/>
+          </a:prstGeom>
+        </p:spPr>
+      </p:pic>
+      <p:pic>
+        <p:nvPicPr>
+          <p:cNvPr id="9" name="图片 8"/>
+          <p:cNvPicPr>
+            <a:picLocks noChangeAspect="1"/>
+          </p:cNvPicPr>
+          <p:nvPr/>
+        </p:nvPicPr>
+        <p:blipFill>
+          <a:blip r:embed="rId2"/>
+          <a:stretch>
+            <a:fillRect/>
+          </a:stretch>
+        </p:blipFill>
+        <p:spPr>
+          <a:xfrm>
+            <a:off x="4852035" y="1662430"/>
+            <a:ext cx="3901440" cy="3041015"/>
+          </a:xfrm>
+          <a:prstGeom prst="rect">
+            <a:avLst/>
+          </a:prstGeom>
+        </p:spPr>
+      </p:pic>
     </p:spTree>
   </p:cSld>
   <p:clrMapOvr>
@@ -3339,7 +3434,7 @@
                 <a:latin typeface="微软雅黑" panose="020B0503020204020204" charset="-122"/>
                 <a:ea typeface="微软雅黑" panose="020B0503020204020204" charset="-122"/>
               </a:rPr>
-              <a:t>Project Links</a:t>
+              <a:t>Technical Report Highlights</a:t>
             </a:r>
             <a:endParaRPr lang="en-US" altLang="zh-CN" sz="1780" b="1" dirty="0">
               <a:latin typeface="微软雅黑" panose="020B0503020204020204" charset="-122"/>
@@ -3485,8 +3580,8 @@
         </p:nvSpPr>
         <p:spPr>
           <a:xfrm>
-            <a:off x="314325" y="1303655"/>
-            <a:ext cx="7049135" cy="2553335"/>
+            <a:off x="1527810" y="1436370"/>
+            <a:ext cx="5996305" cy="2799715"/>
           </a:xfrm>
           <a:prstGeom prst="rect">
             <a:avLst/>
@@ -3504,7 +3599,7 @@
             </a:pPr>
             <a:r>
               <a:rPr lang="en-US" altLang="zh-CN" sz="1600"/>
-              <a:t>GitHub Repository: https://github.com/SHIRUIZHAOIILLiil/housing-api </a:t>
+              <a:t>Architecture: layered FastAPI design with routers, services, and database separation</a:t>
             </a:r>
             <a:endParaRPr lang="en-US" altLang="zh-CN" sz="1600"/>
           </a:p>
@@ -3522,7 +3617,7 @@
             </a:pPr>
             <a:r>
               <a:rPr lang="en-US" altLang="zh-CN" sz="1600"/>
-              <a:t>API Documentation PDF: https://github.com/SHIRUIZHAOIILLiil/housing-api/tree/main/docs/Housing-API.pdf</a:t>
+              <a:t>Design choice: official datasets separated from user-managed editable records</a:t>
             </a:r>
             <a:endParaRPr lang="en-US" altLang="zh-CN" sz="1600"/>
           </a:p>
@@ -3540,13 +3635,7 @@
             </a:pPr>
             <a:r>
               <a:rPr lang="en-US" altLang="zh-CN" sz="1600"/>
-              <a:t>Technical Report PDF: </a:t>
-            </a:r>
-            <a:r>
-              <a:rPr lang="en-US" altLang="zh-CN" sz="1600">
-                <a:sym typeface="+mn-ea"/>
-              </a:rPr>
-              <a:t>https://github.com/SHIRUIZHAOIILLiil/housing-api/tree/main/docs/Housing-API-technical-report.pdf</a:t>
+              <a:t>Technology stack: FastAPI + SQLite chosen for portability, schema-first design, and coursework practicality</a:t>
             </a:r>
             <a:endParaRPr lang="en-US" altLang="zh-CN" sz="1600"/>
           </a:p>
@@ -3564,17 +3653,9 @@
             </a:pPr>
             <a:r>
               <a:rPr lang="en-US" altLang="zh-CN" sz="1600"/>
-              <a:t>Presentation Slides: </a:t>
-            </a:r>
-            <a:r>
-              <a:rPr lang="en-US" altLang="zh-CN" sz="1600">
-                <a:sym typeface="+mn-ea"/>
-              </a:rPr>
-              <a:t>https://github.com/SHIRUIZHAOIILLiil/housing-api/tree/main/docs/Housing-API.pptx</a:t>
-            </a:r>
-            <a:endParaRPr lang="zh-CN" altLang="en-US" sz="1600">
-              <a:sym typeface="+mn-ea"/>
-            </a:endParaRPr>
+              <a:t>Lessons learned: testing improved not just correctness, but API contract clarity</a:t>
+            </a:r>
+            <a:endParaRPr lang="en-US" altLang="zh-CN" sz="1600"/>
           </a:p>
         </p:txBody>
       </p:sp>
@@ -3665,8 +3746,8 @@
         </p:nvSpPr>
         <p:spPr>
           <a:xfrm>
-            <a:off x="185738" y="485775"/>
-            <a:ext cx="5162550" cy="304800"/>
+            <a:off x="186055" y="485775"/>
+            <a:ext cx="7280910" cy="304800"/>
           </a:xfrm>
           <a:prstGeom prst="rect">
             <a:avLst/>
@@ -3684,35 +3765,72 @@
               <a:buNone/>
             </a:pPr>
             <a:r>
-              <a:rPr lang="en-US" sz="1780" b="1" kern="0" spc="-36" dirty="0">
+              <a:rPr lang="en-US" altLang="zh-CN" sz="1780" b="1" dirty="0">
+                <a:latin typeface="微软雅黑" panose="020B0503020204020204" charset="-122"/>
+                <a:ea typeface="微软雅黑" panose="020B0503020204020204" charset="-122"/>
+              </a:rPr>
+              <a:t>Project Links</a:t>
+            </a:r>
+            <a:endParaRPr lang="en-US" altLang="zh-CN" sz="1780" b="1" dirty="0">
+              <a:latin typeface="微软雅黑" panose="020B0503020204020204" charset="-122"/>
+              <a:ea typeface="微软雅黑" panose="020B0503020204020204" charset="-122"/>
+            </a:endParaRPr>
+          </a:p>
+        </p:txBody>
+      </p:sp>
+      <p:sp>
+        <p:nvSpPr>
+          <p:cNvPr id="5" name="Text 3"/>
+          <p:cNvSpPr/>
+          <p:nvPr/>
+        </p:nvSpPr>
+        <p:spPr>
+          <a:xfrm>
+            <a:off x="186055" y="4805680"/>
+            <a:ext cx="2768600" cy="304800"/>
+          </a:xfrm>
+          <a:prstGeom prst="rect">
+            <a:avLst/>
+          </a:prstGeom>
+          <a:noFill/>
+        </p:spPr>
+        <p:txBody>
+          <a:bodyPr wrap="square" lIns="0" tIns="0" rIns="0" bIns="0" rtlCol="0" anchor="ctr"/>
+          <a:lstStyle/>
+          <a:p>
+            <a:pPr marL="0" indent="0" algn="l">
+              <a:lnSpc>
+                <a:spcPts val="2280"/>
+              </a:lnSpc>
+              <a:buNone/>
+            </a:pPr>
+            <a:r>
+              <a:rPr lang="en-US" sz="1425" kern="0" spc="-28" dirty="0">
                 <a:solidFill>
                   <a:srgbClr val="000000">
                     <a:alpha val="99000"/>
                   </a:srgbClr>
                 </a:solidFill>
-                <a:latin typeface="微软雅黑" panose="020B0503020204020204" charset="-122"/>
-                <a:ea typeface="微软雅黑" panose="020B0503020204020204" charset="-122"/>
+                <a:latin typeface="Work Sans" pitchFamily="34" charset="0"/>
+                <a:ea typeface="Work Sans" pitchFamily="34" charset="-122"/>
                 <a:cs typeface="Work Sans" pitchFamily="34" charset="-120"/>
               </a:rPr>
-              <a:t>Reflection, GenAI Usage, and Future Work</a:t>
-            </a:r>
-            <a:endParaRPr lang="en-US" sz="1780" dirty="0">
-              <a:latin typeface="微软雅黑" panose="020B0503020204020204" charset="-122"/>
-              <a:ea typeface="微软雅黑" panose="020B0503020204020204" charset="-122"/>
-            </a:endParaRPr>
-          </a:p>
-        </p:txBody>
-      </p:sp>
-      <p:sp>
-        <p:nvSpPr>
-          <p:cNvPr id="5" name="Text 3"/>
-          <p:cNvSpPr/>
-          <p:nvPr/>
-        </p:nvSpPr>
-        <p:spPr>
-          <a:xfrm>
-            <a:off x="186055" y="4805680"/>
-            <a:ext cx="2352040" cy="304800"/>
+              <a:t>Shirui Zhao</a:t>
+            </a:r>
+            <a:endParaRPr lang="en-US" sz="1425" dirty="0"/>
+          </a:p>
+        </p:txBody>
+      </p:sp>
+      <p:sp>
+        <p:nvSpPr>
+          <p:cNvPr id="6" name="Text 4"/>
+          <p:cNvSpPr/>
+          <p:nvPr/>
+        </p:nvSpPr>
+        <p:spPr>
+          <a:xfrm>
+            <a:off x="6585585" y="4910455"/>
+            <a:ext cx="2367915" cy="114300"/>
           </a:xfrm>
           <a:prstGeom prst="rect">
             <a:avLst/>
@@ -3723,39 +3841,39 @@
           <a:bodyPr wrap="square" lIns="0" tIns="0" rIns="0" bIns="0" rtlCol="0" anchor="ctr"/>
           <a:lstStyle/>
           <a:p>
-            <a:pPr marL="0" indent="0" algn="l">
-              <a:lnSpc>
-                <a:spcPts val="2280"/>
+            <a:pPr marL="0" indent="0" algn="r">
+              <a:lnSpc>
+                <a:spcPts val="865"/>
               </a:lnSpc>
               <a:buNone/>
             </a:pPr>
             <a:r>
-              <a:rPr lang="en-US" sz="1425" kern="0" spc="-28" dirty="0">
+              <a:rPr lang="en-US" sz="785" kern="0" spc="78" dirty="0">
                 <a:solidFill>
                   <a:srgbClr val="000000">
                     <a:alpha val="99000"/>
                   </a:srgbClr>
                 </a:solidFill>
-                <a:latin typeface="Work Sans" pitchFamily="34" charset="0"/>
-                <a:ea typeface="Work Sans" pitchFamily="34" charset="-122"/>
-                <a:cs typeface="Work Sans" pitchFamily="34" charset="-120"/>
-              </a:rPr>
-              <a:t>Shirui Zhao</a:t>
-            </a:r>
-            <a:endParaRPr lang="en-US" sz="1425" dirty="0"/>
-          </a:p>
-        </p:txBody>
-      </p:sp>
-      <p:sp>
-        <p:nvSpPr>
-          <p:cNvPr id="6" name="Text 4"/>
-          <p:cNvSpPr/>
-          <p:nvPr/>
-        </p:nvSpPr>
-        <p:spPr>
-          <a:xfrm>
-            <a:off x="7652385" y="4910455"/>
-            <a:ext cx="1301115" cy="114300"/>
+                <a:latin typeface="Cutive Mono" pitchFamily="34" charset="0"/>
+                <a:ea typeface="Cutive Mono" pitchFamily="34" charset="-122"/>
+                <a:cs typeface="Cutive Mono" pitchFamily="34" charset="-120"/>
+              </a:rPr>
+              <a:t>2026-03-12</a:t>
+            </a:r>
+            <a:endParaRPr lang="en-US" sz="785" dirty="0"/>
+          </a:p>
+        </p:txBody>
+      </p:sp>
+      <p:sp>
+        <p:nvSpPr>
+          <p:cNvPr id="7" name="Text 5"/>
+          <p:cNvSpPr/>
+          <p:nvPr/>
+        </p:nvSpPr>
+        <p:spPr>
+          <a:xfrm>
+            <a:off x="190500" y="142875"/>
+            <a:ext cx="6637655" cy="114300"/>
           </a:xfrm>
           <a:prstGeom prst="rect">
             <a:avLst/>
@@ -3766,7 +3884,7 @@
           <a:bodyPr wrap="square" lIns="0" tIns="0" rIns="0" bIns="0" rtlCol="0" anchor="ctr"/>
           <a:lstStyle/>
           <a:p>
-            <a:pPr marL="0" indent="0" algn="r">
+            <a:pPr marL="0" indent="0" algn="l">
               <a:lnSpc>
                 <a:spcPts val="865"/>
               </a:lnSpc>
@@ -3783,7 +3901,7 @@
                 <a:ea typeface="Cutive Mono" pitchFamily="34" charset="-122"/>
                 <a:cs typeface="Cutive Mono" pitchFamily="34" charset="-120"/>
               </a:rPr>
-              <a:t>2026-03-12</a:t>
+              <a:t>COMP3011 COURSEWORK 1 – INDIVIDUAL WEB SERVICES API DEVELOPMENT PROJECT</a:t>
             </a:r>
             <a:endParaRPr lang="en-US" sz="785" dirty="0"/>
           </a:p>
@@ -3791,719 +3909,105 @@
       </p:sp>
       <p:sp>
         <p:nvSpPr>
-          <p:cNvPr id="7" name="Text 5"/>
-          <p:cNvSpPr/>
-          <p:nvPr/>
-        </p:nvSpPr>
-        <p:spPr>
-          <a:xfrm>
-            <a:off x="190500" y="142875"/>
-            <a:ext cx="5238750" cy="114300"/>
-          </a:xfrm>
-          <a:prstGeom prst="rect">
-            <a:avLst/>
-          </a:prstGeom>
-          <a:noFill/>
-        </p:spPr>
-        <p:txBody>
-          <a:bodyPr wrap="square" lIns="0" tIns="0" rIns="0" bIns="0" rtlCol="0" anchor="ctr"/>
-          <a:lstStyle/>
-          <a:p>
-            <a:pPr marL="0" indent="0" algn="l">
-              <a:lnSpc>
-                <a:spcPts val="865"/>
-              </a:lnSpc>
-              <a:buNone/>
-            </a:pPr>
-            <a:r>
-              <a:rPr lang="en-US" sz="785" kern="0" spc="78" dirty="0">
-                <a:solidFill>
-                  <a:srgbClr val="000000">
-                    <a:alpha val="99000"/>
-                  </a:srgbClr>
-                </a:solidFill>
-                <a:latin typeface="Cutive Mono" pitchFamily="34" charset="0"/>
-                <a:ea typeface="Cutive Mono" pitchFamily="34" charset="-122"/>
-                <a:cs typeface="Cutive Mono" pitchFamily="34" charset="-120"/>
-              </a:rPr>
-              <a:t>COMP3011 COURSEWORK 1 – INDIVIDUAL WEB SERVICES API DEVELOPMENT PROJECT</a:t>
-            </a:r>
-            <a:endParaRPr lang="en-US" sz="785" dirty="0"/>
-          </a:p>
-        </p:txBody>
-      </p:sp>
-      <p:sp>
-        <p:nvSpPr>
-          <p:cNvPr id="8" name="Text 6"/>
-          <p:cNvSpPr/>
-          <p:nvPr>
-            <p:custDataLst>
-              <p:tags r:id="rId1"/>
-            </p:custDataLst>
-          </p:nvPr>
-        </p:nvSpPr>
-        <p:spPr>
-          <a:xfrm>
-            <a:off x="171450" y="1019175"/>
-            <a:ext cx="581025" cy="581025"/>
-          </a:xfrm>
-          <a:prstGeom prst="ellipse">
-            <a:avLst/>
-          </a:prstGeom>
-          <a:solidFill>
-            <a:srgbClr val="DCDBCE"/>
-          </a:solidFill>
-          <a:ln w="9049">
-            <a:solidFill>
-              <a:srgbClr val="000000"/>
-            </a:solidFill>
-          </a:ln>
-        </p:spPr>
-        <p:txBody>
-          <a:bodyPr wrap="square" rtlCol="0" anchor="ctr"/>
-          <a:lstStyle/>
-          <a:p>
-            <a:pPr marL="0" indent="0">
-              <a:buNone/>
-            </a:pPr>
-            <a:r>
-              <a:rPr lang="en-US" dirty="0">
-                <a:solidFill>
-                  <a:srgbClr val="000000"/>
-                </a:solidFill>
-              </a:rPr>
-              <a:t>A</a:t>
-            </a:r>
-            <a:endParaRPr lang="en-US" dirty="0"/>
-          </a:p>
-        </p:txBody>
-      </p:sp>
-      <p:sp>
-        <p:nvSpPr>
-          <p:cNvPr id="9" name="Text 7"/>
-          <p:cNvSpPr/>
-          <p:nvPr>
-            <p:custDataLst>
-              <p:tags r:id="rId2"/>
-            </p:custDataLst>
-          </p:nvPr>
-        </p:nvSpPr>
-        <p:spPr>
-          <a:xfrm>
-            <a:off x="3157538" y="1019175"/>
-            <a:ext cx="581025" cy="581025"/>
-          </a:xfrm>
-          <a:prstGeom prst="ellipse">
-            <a:avLst/>
-          </a:prstGeom>
-          <a:solidFill>
-            <a:srgbClr val="DCDBCE"/>
-          </a:solidFill>
-          <a:ln w="9049">
-            <a:solidFill>
-              <a:srgbClr val="000000"/>
-            </a:solidFill>
-          </a:ln>
-        </p:spPr>
-        <p:txBody>
-          <a:bodyPr wrap="square" rtlCol="0" anchor="ctr"/>
-          <a:lstStyle/>
-          <a:p>
-            <a:pPr marL="0" indent="0">
-              <a:buNone/>
-            </a:pPr>
-            <a:r>
-              <a:rPr lang="en-US" dirty="0">
-                <a:solidFill>
-                  <a:srgbClr val="000000"/>
-                </a:solidFill>
-              </a:rPr>
-              <a:t>B</a:t>
-            </a:r>
-            <a:endParaRPr lang="en-US" dirty="0"/>
-          </a:p>
-        </p:txBody>
-      </p:sp>
-      <p:sp>
-        <p:nvSpPr>
-          <p:cNvPr id="10" name="Text 8"/>
-          <p:cNvSpPr/>
-          <p:nvPr>
-            <p:custDataLst>
-              <p:tags r:id="rId3"/>
-            </p:custDataLst>
-          </p:nvPr>
-        </p:nvSpPr>
-        <p:spPr>
-          <a:xfrm>
-            <a:off x="6138863" y="1019175"/>
-            <a:ext cx="581025" cy="581025"/>
-          </a:xfrm>
-          <a:prstGeom prst="ellipse">
-            <a:avLst/>
-          </a:prstGeom>
-          <a:solidFill>
-            <a:srgbClr val="DCDBCE"/>
-          </a:solidFill>
-          <a:ln w="9049">
-            <a:solidFill>
-              <a:srgbClr val="000000"/>
-            </a:solidFill>
-          </a:ln>
-        </p:spPr>
-        <p:txBody>
-          <a:bodyPr wrap="square" rtlCol="0" anchor="ctr"/>
-          <a:lstStyle/>
-          <a:p>
-            <a:pPr marL="0" indent="0">
-              <a:buNone/>
-            </a:pPr>
-            <a:r>
-              <a:rPr lang="en-US" dirty="0">
-                <a:solidFill>
-                  <a:srgbClr val="000000"/>
-                </a:solidFill>
-              </a:rPr>
-              <a:t>C</a:t>
-            </a:r>
-            <a:endParaRPr lang="en-US" dirty="0"/>
-          </a:p>
-        </p:txBody>
-      </p:sp>
-      <p:sp>
-        <p:nvSpPr>
-          <p:cNvPr id="11" name="Text 9"/>
-          <p:cNvSpPr/>
-          <p:nvPr>
-            <p:custDataLst>
-              <p:tags r:id="rId4"/>
-            </p:custDataLst>
-          </p:nvPr>
-        </p:nvSpPr>
-        <p:spPr>
-          <a:xfrm>
-            <a:off x="866775" y="1171575"/>
-            <a:ext cx="2290763" cy="276225"/>
-          </a:xfrm>
-          <a:prstGeom prst="rect">
-            <a:avLst/>
-          </a:prstGeom>
-          <a:noFill/>
-        </p:spPr>
-        <p:txBody>
-          <a:bodyPr wrap="square" lIns="0" tIns="0" rIns="0" bIns="0" rtlCol="0" anchor="ctr"/>
-          <a:lstStyle/>
-          <a:p>
-            <a:pPr marL="0" indent="0" algn="l">
-              <a:lnSpc>
-                <a:spcPts val="2060"/>
-              </a:lnSpc>
-              <a:buNone/>
-            </a:pPr>
-            <a:r>
-              <a:rPr lang="en-US" sz="1425" kern="0" spc="-28" dirty="0">
-                <a:solidFill>
-                  <a:srgbClr val="000000">
-                    <a:alpha val="99000"/>
-                  </a:srgbClr>
-                </a:solidFill>
-                <a:latin typeface="微软雅黑" panose="020B0503020204020204" charset="-122"/>
-                <a:ea typeface="微软雅黑" panose="020B0503020204020204" charset="-122"/>
-                <a:cs typeface="Work Sans" pitchFamily="34" charset="-120"/>
-              </a:rPr>
-              <a:t> Reflection</a:t>
-            </a:r>
-            <a:endParaRPr lang="en-US" sz="1425" dirty="0">
-              <a:latin typeface="微软雅黑" panose="020B0503020204020204" charset="-122"/>
-              <a:ea typeface="微软雅黑" panose="020B0503020204020204" charset="-122"/>
+          <p:cNvPr id="22" name="文本框 21"/>
+          <p:cNvSpPr txBox="1"/>
+          <p:nvPr/>
+        </p:nvSpPr>
+        <p:spPr>
+          <a:xfrm>
+            <a:off x="314325" y="1303655"/>
+            <a:ext cx="7049135" cy="2553335"/>
+          </a:xfrm>
+          <a:prstGeom prst="rect">
+            <a:avLst/>
+          </a:prstGeom>
+          <a:noFill/>
+        </p:spPr>
+        <p:txBody>
+          <a:bodyPr wrap="square" rtlCol="0">
+            <a:spAutoFit/>
+          </a:bodyPr>
+          <a:p>
+            <a:pPr marL="285750" indent="-285750">
+              <a:buFont typeface="Wingdings" panose="05000000000000000000" charset="0"/>
+              <a:buChar char="l"/>
+            </a:pPr>
+            <a:r>
+              <a:rPr lang="en-US" altLang="zh-CN" sz="1600"/>
+              <a:t>GitHub Repository: https://github.com/SHIRUIZHAOIILLiil/housing-api </a:t>
+            </a:r>
+            <a:endParaRPr lang="en-US" altLang="zh-CN" sz="1600"/>
+          </a:p>
+          <a:p>
+            <a:pPr marL="285750" indent="-285750">
+              <a:buFont typeface="Wingdings" panose="05000000000000000000" charset="0"/>
+              <a:buChar char="l"/>
+            </a:pPr>
+            <a:endParaRPr lang="en-US" altLang="zh-CN" sz="1600"/>
+          </a:p>
+          <a:p>
+            <a:pPr marL="285750" indent="-285750">
+              <a:buFont typeface="Wingdings" panose="05000000000000000000" charset="0"/>
+              <a:buChar char="l"/>
+            </a:pPr>
+            <a:r>
+              <a:rPr lang="en-US" altLang="zh-CN" sz="1600"/>
+              <a:t>API Documentation PDF: https://github.com/SHIRUIZHAOIILLiil/housing-api/tree/main/docs/Housing-API.pdf</a:t>
+            </a:r>
+            <a:endParaRPr lang="en-US" altLang="zh-CN" sz="1600"/>
+          </a:p>
+          <a:p>
+            <a:pPr marL="285750" indent="-285750">
+              <a:buFont typeface="Wingdings" panose="05000000000000000000" charset="0"/>
+              <a:buChar char="l"/>
+            </a:pPr>
+            <a:endParaRPr lang="en-US" altLang="zh-CN" sz="1600"/>
+          </a:p>
+          <a:p>
+            <a:pPr marL="285750" indent="-285750">
+              <a:buFont typeface="Wingdings" panose="05000000000000000000" charset="0"/>
+              <a:buChar char="l"/>
+            </a:pPr>
+            <a:r>
+              <a:rPr lang="en-US" altLang="zh-CN" sz="1600"/>
+              <a:t>Technical Report PDF: </a:t>
+            </a:r>
+            <a:r>
+              <a:rPr lang="en-US" altLang="zh-CN" sz="1600">
+                <a:sym typeface="+mn-ea"/>
+              </a:rPr>
+              <a:t>https://github.com/SHIRUIZHAOIILLiil/housing-api/tree/main/docs/Housing-API-technical-report.pdf</a:t>
+            </a:r>
+            <a:endParaRPr lang="en-US" altLang="zh-CN" sz="1600"/>
+          </a:p>
+          <a:p>
+            <a:pPr marL="285750" indent="-285750">
+              <a:buFont typeface="Wingdings" panose="05000000000000000000" charset="0"/>
+              <a:buChar char="l"/>
+            </a:pPr>
+            <a:endParaRPr lang="en-US" altLang="zh-CN" sz="1600"/>
+          </a:p>
+          <a:p>
+            <a:pPr marL="285750" indent="-285750">
+              <a:buFont typeface="Wingdings" panose="05000000000000000000" charset="0"/>
+              <a:buChar char="l"/>
+            </a:pPr>
+            <a:r>
+              <a:rPr lang="en-US" altLang="zh-CN" sz="1600"/>
+              <a:t>Presentation Slides: </a:t>
+            </a:r>
+            <a:r>
+              <a:rPr lang="en-US" altLang="zh-CN" sz="1600">
+                <a:sym typeface="+mn-ea"/>
+              </a:rPr>
+              <a:t>https://github.com/SHIRUIZHAOIILLiil/housing-api/tree/main/docs/Housing-API.pptx</a:t>
+            </a:r>
+            <a:endParaRPr lang="zh-CN" altLang="en-US" sz="1600">
+              <a:sym typeface="+mn-ea"/>
             </a:endParaRPr>
           </a:p>
         </p:txBody>
       </p:sp>
-      <p:sp>
-        <p:nvSpPr>
-          <p:cNvPr id="12" name="Text 10"/>
-          <p:cNvSpPr/>
-          <p:nvPr>
-            <p:custDataLst>
-              <p:tags r:id="rId5"/>
-            </p:custDataLst>
-          </p:nvPr>
-        </p:nvSpPr>
-        <p:spPr>
-          <a:xfrm>
-            <a:off x="3848100" y="1171575"/>
-            <a:ext cx="2290763" cy="276225"/>
-          </a:xfrm>
-          <a:prstGeom prst="rect">
-            <a:avLst/>
-          </a:prstGeom>
-          <a:noFill/>
-        </p:spPr>
-        <p:txBody>
-          <a:bodyPr wrap="square" lIns="0" tIns="0" rIns="0" bIns="0" rtlCol="0" anchor="ctr"/>
-          <a:lstStyle/>
-          <a:p>
-            <a:pPr marL="0" indent="0" algn="l">
-              <a:lnSpc>
-                <a:spcPts val="2060"/>
-              </a:lnSpc>
-              <a:buNone/>
-            </a:pPr>
-            <a:r>
-              <a:rPr lang="en-US" sz="1425" kern="0" spc="-28" dirty="0">
-                <a:solidFill>
-                  <a:srgbClr val="000000">
-                    <a:alpha val="99000"/>
-                  </a:srgbClr>
-                </a:solidFill>
-                <a:latin typeface="微软雅黑" panose="020B0503020204020204" charset="-122"/>
-                <a:ea typeface="微软雅黑" panose="020B0503020204020204" charset="-122"/>
-                <a:cs typeface="Work Sans" pitchFamily="34" charset="-120"/>
-              </a:rPr>
-              <a:t>GenAI Usage</a:t>
-            </a:r>
-            <a:endParaRPr lang="en-US" sz="1425" dirty="0">
-              <a:latin typeface="微软雅黑" panose="020B0503020204020204" charset="-122"/>
-              <a:ea typeface="微软雅黑" panose="020B0503020204020204" charset="-122"/>
-            </a:endParaRPr>
-          </a:p>
-        </p:txBody>
-      </p:sp>
-      <p:sp>
-        <p:nvSpPr>
-          <p:cNvPr id="13" name="Text 11"/>
-          <p:cNvSpPr/>
-          <p:nvPr>
-            <p:custDataLst>
-              <p:tags r:id="rId6"/>
-            </p:custDataLst>
-          </p:nvPr>
-        </p:nvSpPr>
-        <p:spPr>
-          <a:xfrm>
-            <a:off x="6829425" y="1171575"/>
-            <a:ext cx="2290763" cy="276225"/>
-          </a:xfrm>
-          <a:prstGeom prst="rect">
-            <a:avLst/>
-          </a:prstGeom>
-          <a:noFill/>
-        </p:spPr>
-        <p:txBody>
-          <a:bodyPr wrap="square" lIns="0" tIns="0" rIns="0" bIns="0" rtlCol="0" anchor="ctr"/>
-          <a:lstStyle/>
-          <a:p>
-            <a:pPr marL="0" indent="0" algn="l">
-              <a:lnSpc>
-                <a:spcPts val="2060"/>
-              </a:lnSpc>
-              <a:buNone/>
-            </a:pPr>
-            <a:r>
-              <a:rPr lang="en-US" sz="1425" kern="0" spc="-28" dirty="0">
-                <a:solidFill>
-                  <a:srgbClr val="000000">
-                    <a:alpha val="99000"/>
-                  </a:srgbClr>
-                </a:solidFill>
-                <a:latin typeface="微软雅黑" panose="020B0503020204020204" charset="-122"/>
-                <a:ea typeface="微软雅黑" panose="020B0503020204020204" charset="-122"/>
-                <a:cs typeface="Work Sans" pitchFamily="34" charset="-120"/>
-              </a:rPr>
-              <a:t>Future Work</a:t>
-            </a:r>
-            <a:endParaRPr lang="en-US" sz="1425" dirty="0">
-              <a:latin typeface="微软雅黑" panose="020B0503020204020204" charset="-122"/>
-              <a:ea typeface="微软雅黑" panose="020B0503020204020204" charset="-122"/>
-            </a:endParaRPr>
-          </a:p>
-        </p:txBody>
-      </p:sp>
-      <p:sp>
-        <p:nvSpPr>
-          <p:cNvPr id="14" name="Text 12"/>
-          <p:cNvSpPr/>
-          <p:nvPr>
-            <p:custDataLst>
-              <p:tags r:id="rId7"/>
-            </p:custDataLst>
-          </p:nvPr>
-        </p:nvSpPr>
-        <p:spPr>
-          <a:xfrm>
-            <a:off x="85725" y="1728470"/>
-            <a:ext cx="2914015" cy="1652905"/>
-          </a:xfrm>
-          <a:prstGeom prst="rect">
-            <a:avLst/>
-          </a:prstGeom>
-          <a:noFill/>
-        </p:spPr>
-        <p:txBody>
-          <a:bodyPr wrap="square" lIns="0" tIns="0" rIns="0" bIns="0" rtlCol="0" anchor="ctr"/>
-          <a:lstStyle/>
-          <a:p>
-            <a:pPr marL="342900" indent="-342900" algn="l">
-              <a:lnSpc>
-                <a:spcPts val="2060"/>
-              </a:lnSpc>
-              <a:buSzPct val="100000"/>
-              <a:buChar char="•"/>
-            </a:pPr>
-            <a:r>
-              <a:rPr lang="en-US" sz="855" kern="0" spc="-17" dirty="0">
-                <a:solidFill>
-                  <a:srgbClr val="000000">
-                    <a:alpha val="99000"/>
-                  </a:srgbClr>
-                </a:solidFill>
-                <a:latin typeface="微软雅黑" panose="020B0503020204020204" charset="-122"/>
-                <a:ea typeface="微软雅黑" panose="020B0503020204020204" charset="-122"/>
-                <a:cs typeface="Work Sans" pitchFamily="34" charset="-120"/>
-              </a:rPr>
-              <a:t>Learned practical REST API design and data modelling</a:t>
-            </a:r>
-            <a:endParaRPr lang="en-US" sz="855" dirty="0">
-              <a:latin typeface="微软雅黑" panose="020B0503020204020204" charset="-122"/>
-              <a:ea typeface="微软雅黑" panose="020B0503020204020204" charset="-122"/>
-            </a:endParaRPr>
-          </a:p>
-          <a:p>
-            <a:pPr marL="342900" indent="-342900" algn="l">
-              <a:lnSpc>
-                <a:spcPts val="2060"/>
-              </a:lnSpc>
-              <a:buSzPct val="100000"/>
-              <a:buChar char="•"/>
-            </a:pPr>
-            <a:r>
-              <a:rPr lang="en-US" sz="855" kern="0" spc="-17" dirty="0">
-                <a:solidFill>
-                  <a:srgbClr val="000000">
-                    <a:alpha val="99000"/>
-                  </a:srgbClr>
-                </a:solidFill>
-                <a:latin typeface="微软雅黑" panose="020B0503020204020204" charset="-122"/>
-                <a:ea typeface="微软雅黑" panose="020B0503020204020204" charset="-122"/>
-                <a:cs typeface="Work Sans" pitchFamily="34" charset="-120"/>
-              </a:rPr>
-              <a:t>Improved testing, debugging, and project structuring skills</a:t>
-            </a:r>
-            <a:endParaRPr lang="en-US" sz="855" dirty="0">
-              <a:latin typeface="微软雅黑" panose="020B0503020204020204" charset="-122"/>
-              <a:ea typeface="微软雅黑" panose="020B0503020204020204" charset="-122"/>
-            </a:endParaRPr>
-          </a:p>
-          <a:p>
-            <a:pPr marL="342900" indent="-342900" algn="l">
-              <a:lnSpc>
-                <a:spcPts val="2060"/>
-              </a:lnSpc>
-              <a:buSzPct val="100000"/>
-              <a:buChar char="•"/>
-            </a:pPr>
-            <a:r>
-              <a:rPr lang="en-US" sz="855" kern="0" spc="-17" dirty="0">
-                <a:solidFill>
-                  <a:srgbClr val="000000">
-                    <a:alpha val="99000"/>
-                  </a:srgbClr>
-                </a:solidFill>
-                <a:latin typeface="微软雅黑" panose="020B0503020204020204" charset="-122"/>
-                <a:ea typeface="微软雅黑" panose="020B0503020204020204" charset="-122"/>
-                <a:cs typeface="Work Sans" pitchFamily="34" charset="-120"/>
-              </a:rPr>
-              <a:t>Better understood how to turn raw datasets into usable services</a:t>
-            </a:r>
-            <a:endParaRPr lang="en-US" sz="855" dirty="0">
-              <a:latin typeface="微软雅黑" panose="020B0503020204020204" charset="-122"/>
-              <a:ea typeface="微软雅黑" panose="020B0503020204020204" charset="-122"/>
-            </a:endParaRPr>
-          </a:p>
-        </p:txBody>
-      </p:sp>
-      <p:sp>
-        <p:nvSpPr>
-          <p:cNvPr id="15" name="Text 13"/>
-          <p:cNvSpPr/>
-          <p:nvPr>
-            <p:custDataLst>
-              <p:tags r:id="rId8"/>
-            </p:custDataLst>
-          </p:nvPr>
-        </p:nvSpPr>
-        <p:spPr>
-          <a:xfrm>
-            <a:off x="6138863" y="1614488"/>
-            <a:ext cx="2814638" cy="1652588"/>
-          </a:xfrm>
-          <a:prstGeom prst="rect">
-            <a:avLst/>
-          </a:prstGeom>
-          <a:noFill/>
-        </p:spPr>
-        <p:txBody>
-          <a:bodyPr wrap="square" lIns="0" tIns="0" rIns="0" bIns="0" rtlCol="0" anchor="ctr"/>
-          <a:lstStyle/>
-          <a:p>
-            <a:pPr marL="342900" indent="-342900" algn="l">
-              <a:lnSpc>
-                <a:spcPts val="2060"/>
-              </a:lnSpc>
-              <a:buSzPct val="100000"/>
-              <a:buChar char="•"/>
-            </a:pPr>
-            <a:r>
-              <a:rPr lang="en-US" sz="855" kern="0" spc="-17" dirty="0">
-                <a:solidFill>
-                  <a:srgbClr val="000000">
-                    <a:alpha val="99000"/>
-                  </a:srgbClr>
-                </a:solidFill>
-                <a:latin typeface="微软雅黑" panose="020B0503020204020204" charset="-122"/>
-                <a:ea typeface="微软雅黑" panose="020B0503020204020204" charset="-122"/>
-                <a:cs typeface="Work Sans" pitchFamily="34" charset="-120"/>
-              </a:rPr>
-              <a:t>Add richer analytics and comparison endpoints</a:t>
-            </a:r>
-            <a:endParaRPr lang="en-US" sz="855" dirty="0">
-              <a:latin typeface="微软雅黑" panose="020B0503020204020204" charset="-122"/>
-              <a:ea typeface="微软雅黑" panose="020B0503020204020204" charset="-122"/>
-            </a:endParaRPr>
-          </a:p>
-          <a:p>
-            <a:pPr marL="342900" indent="-342900" algn="l">
-              <a:lnSpc>
-                <a:spcPts val="2060"/>
-              </a:lnSpc>
-              <a:buSzPct val="100000"/>
-              <a:buChar char="•"/>
-            </a:pPr>
-            <a:r>
-              <a:rPr lang="en-US" sz="855" kern="0" spc="-17" dirty="0">
-                <a:solidFill>
-                  <a:srgbClr val="000000">
-                    <a:alpha val="99000"/>
-                  </a:srgbClr>
-                </a:solidFill>
-                <a:latin typeface="微软雅黑" panose="020B0503020204020204" charset="-122"/>
-                <a:ea typeface="微软雅黑" panose="020B0503020204020204" charset="-122"/>
-                <a:cs typeface="Work Sans" pitchFamily="34" charset="-120"/>
-              </a:rPr>
-              <a:t>Introduce role-based authorization and stronger security controls</a:t>
-            </a:r>
-            <a:endParaRPr lang="en-US" sz="855" dirty="0">
-              <a:latin typeface="微软雅黑" panose="020B0503020204020204" charset="-122"/>
-              <a:ea typeface="微软雅黑" panose="020B0503020204020204" charset="-122"/>
-            </a:endParaRPr>
-          </a:p>
-          <a:p>
-            <a:pPr marL="342900" indent="-342900" algn="l">
-              <a:lnSpc>
-                <a:spcPts val="2060"/>
-              </a:lnSpc>
-              <a:buSzPct val="100000"/>
-              <a:buChar char="•"/>
-            </a:pPr>
-            <a:r>
-              <a:rPr lang="en-US" sz="855" kern="0" spc="-17" dirty="0">
-                <a:solidFill>
-                  <a:srgbClr val="000000">
-                    <a:alpha val="99000"/>
-                  </a:srgbClr>
-                </a:solidFill>
-                <a:latin typeface="微软雅黑" panose="020B0503020204020204" charset="-122"/>
-                <a:ea typeface="微软雅黑" panose="020B0503020204020204" charset="-122"/>
-                <a:cs typeface="Work Sans" pitchFamily="34" charset="-120"/>
-              </a:rPr>
-              <a:t>Move to cloud database and more production-ready deployment</a:t>
-            </a:r>
-            <a:endParaRPr lang="en-US" sz="855" dirty="0">
-              <a:latin typeface="微软雅黑" panose="020B0503020204020204" charset="-122"/>
-              <a:ea typeface="微软雅黑" panose="020B0503020204020204" charset="-122"/>
-            </a:endParaRPr>
-          </a:p>
-        </p:txBody>
-      </p:sp>
-      <p:sp>
-        <p:nvSpPr>
-          <p:cNvPr id="16" name="Text 14"/>
-          <p:cNvSpPr/>
-          <p:nvPr>
-            <p:custDataLst>
-              <p:tags r:id="rId9"/>
-            </p:custDataLst>
-          </p:nvPr>
-        </p:nvSpPr>
-        <p:spPr>
-          <a:xfrm>
-            <a:off x="3157538" y="1728153"/>
-            <a:ext cx="2628900" cy="1652588"/>
-          </a:xfrm>
-          <a:prstGeom prst="rect">
-            <a:avLst/>
-          </a:prstGeom>
-          <a:noFill/>
-        </p:spPr>
-        <p:txBody>
-          <a:bodyPr wrap="square" lIns="0" tIns="0" rIns="0" bIns="0" rtlCol="0" anchor="ctr"/>
-          <a:lstStyle/>
-          <a:p>
-            <a:pPr marL="342900" indent="-342900" algn="l">
-              <a:lnSpc>
-                <a:spcPts val="2060"/>
-              </a:lnSpc>
-              <a:buSzPct val="100000"/>
-              <a:buChar char="•"/>
-            </a:pPr>
-            <a:r>
-              <a:rPr lang="en-US" sz="855" kern="0" spc="-17" dirty="0">
-                <a:solidFill>
-                  <a:srgbClr val="000000">
-                    <a:alpha val="99000"/>
-                  </a:srgbClr>
-                </a:solidFill>
-                <a:latin typeface="微软雅黑" panose="020B0503020204020204" charset="-122"/>
-                <a:ea typeface="微软雅黑" panose="020B0503020204020204" charset="-122"/>
-                <a:cs typeface="Work Sans" pitchFamily="34" charset="-120"/>
-              </a:rPr>
-              <a:t>Used GenAI for planning, debugging, and refining design ideas</a:t>
-            </a:r>
-            <a:endParaRPr lang="en-US" sz="855" dirty="0">
-              <a:latin typeface="微软雅黑" panose="020B0503020204020204" charset="-122"/>
-              <a:ea typeface="微软雅黑" panose="020B0503020204020204" charset="-122"/>
-            </a:endParaRPr>
-          </a:p>
-          <a:p>
-            <a:pPr marL="342900" indent="-342900" algn="l">
-              <a:lnSpc>
-                <a:spcPts val="2060"/>
-              </a:lnSpc>
-              <a:buSzPct val="100000"/>
-              <a:buChar char="•"/>
-            </a:pPr>
-            <a:r>
-              <a:rPr lang="en-US" sz="855" kern="0" spc="-17" dirty="0">
-                <a:solidFill>
-                  <a:srgbClr val="000000">
-                    <a:alpha val="99000"/>
-                  </a:srgbClr>
-                </a:solidFill>
-                <a:latin typeface="微软雅黑" panose="020B0503020204020204" charset="-122"/>
-                <a:ea typeface="微软雅黑" panose="020B0503020204020204" charset="-122"/>
-                <a:cs typeface="Work Sans" pitchFamily="34" charset="-120"/>
-              </a:rPr>
-              <a:t>Outputs were reviewed, adapted, and validated before use</a:t>
-            </a:r>
-            <a:endParaRPr lang="en-US" sz="855" dirty="0">
-              <a:latin typeface="微软雅黑" panose="020B0503020204020204" charset="-122"/>
-              <a:ea typeface="微软雅黑" panose="020B0503020204020204" charset="-122"/>
-            </a:endParaRPr>
-          </a:p>
-          <a:p>
-            <a:pPr marL="342900" indent="-342900" algn="l">
-              <a:lnSpc>
-                <a:spcPts val="2060"/>
-              </a:lnSpc>
-              <a:buSzPct val="100000"/>
-              <a:buChar char="•"/>
-            </a:pPr>
-            <a:r>
-              <a:rPr lang="en-US" sz="855" kern="0" spc="-17" dirty="0">
-                <a:solidFill>
-                  <a:srgbClr val="000000">
-                    <a:alpha val="99000"/>
-                  </a:srgbClr>
-                </a:solidFill>
-                <a:latin typeface="微软雅黑" panose="020B0503020204020204" charset="-122"/>
-                <a:ea typeface="微软雅黑" panose="020B0503020204020204" charset="-122"/>
-                <a:cs typeface="Work Sans" pitchFamily="34" charset="-120"/>
-              </a:rPr>
-              <a:t>Usage was documented in the report with supporting evidence</a:t>
-            </a:r>
-            <a:endParaRPr lang="en-US" sz="855" dirty="0">
-              <a:latin typeface="微软雅黑" panose="020B0503020204020204" charset="-122"/>
-              <a:ea typeface="微软雅黑" panose="020B0503020204020204" charset="-122"/>
-            </a:endParaRPr>
-          </a:p>
-        </p:txBody>
-      </p:sp>
-      <p:pic>
-        <p:nvPicPr>
-          <p:cNvPr id="17" name="Image 0" descr="preencoded.png"/>
-          <p:cNvPicPr>
-            <a:picLocks noChangeAspect="1"/>
-          </p:cNvPicPr>
-          <p:nvPr/>
-        </p:nvPicPr>
-        <p:blipFill>
-          <a:blip r:embed="rId10"/>
-          <a:srcRect/>
-          <a:stretch>
-            <a:fillRect/>
-          </a:stretch>
-        </p:blipFill>
-        <p:spPr>
-          <a:xfrm>
-            <a:off x="128588" y="3581083"/>
-            <a:ext cx="2681288" cy="638175"/>
-          </a:xfrm>
-          <a:prstGeom prst="rect">
-            <a:avLst/>
-          </a:prstGeom>
-        </p:spPr>
-      </p:pic>
-      <p:pic>
-        <p:nvPicPr>
-          <p:cNvPr id="18" name="Image 1" descr="preencoded.png"/>
-          <p:cNvPicPr>
-            <a:picLocks noChangeAspect="1"/>
-          </p:cNvPicPr>
-          <p:nvPr/>
-        </p:nvPicPr>
-        <p:blipFill>
-          <a:blip r:embed="rId11"/>
-          <a:srcRect/>
-          <a:stretch>
-            <a:fillRect/>
-          </a:stretch>
-        </p:blipFill>
-        <p:spPr>
-          <a:xfrm>
-            <a:off x="3343275" y="3434080"/>
-            <a:ext cx="2085975" cy="1266825"/>
-          </a:xfrm>
-          <a:prstGeom prst="rect">
-            <a:avLst/>
-          </a:prstGeom>
-        </p:spPr>
-      </p:pic>
-      <p:pic>
-        <p:nvPicPr>
-          <p:cNvPr id="19" name="Image 2" descr="preencoded.png"/>
-          <p:cNvPicPr>
-            <a:picLocks noChangeAspect="1"/>
-          </p:cNvPicPr>
-          <p:nvPr/>
-        </p:nvPicPr>
-        <p:blipFill>
-          <a:blip r:embed="rId12"/>
-          <a:srcRect/>
-          <a:stretch>
-            <a:fillRect/>
-          </a:stretch>
-        </p:blipFill>
-        <p:spPr>
-          <a:xfrm>
-            <a:off x="6429375" y="3381375"/>
-            <a:ext cx="2138363" cy="471488"/>
-          </a:xfrm>
-          <a:prstGeom prst="rect">
-            <a:avLst/>
-          </a:prstGeom>
-        </p:spPr>
-      </p:pic>
     </p:spTree>
   </p:cSld>
   <p:clrMapOvr>
@@ -4585,14 +4089,14 @@
       </p:sp>
       <p:sp>
         <p:nvSpPr>
-          <p:cNvPr id="5" name="Text 3"/>
-          <p:cNvSpPr/>
-          <p:nvPr/>
-        </p:nvSpPr>
-        <p:spPr>
-          <a:xfrm>
-            <a:off x="186055" y="4805680"/>
-            <a:ext cx="2352040" cy="304800"/>
+          <p:cNvPr id="4" name="Text 2"/>
+          <p:cNvSpPr/>
+          <p:nvPr/>
+        </p:nvSpPr>
+        <p:spPr>
+          <a:xfrm>
+            <a:off x="185738" y="485775"/>
+            <a:ext cx="5162550" cy="304800"/>
           </a:xfrm>
           <a:prstGeom prst="rect">
             <a:avLst/>
@@ -4610,12 +4114,58 @@
               <a:buNone/>
             </a:pPr>
             <a:r>
-              <a:rPr lang="en-US" sz="1425" kern="0" spc="-28" dirty="0">
+              <a:rPr lang="en-US" sz="1780" b="1" kern="0" spc="-36" dirty="0">
                 <a:solidFill>
                   <a:srgbClr val="000000">
                     <a:alpha val="99000"/>
                   </a:srgbClr>
                 </a:solidFill>
+                <a:latin typeface="微软雅黑" panose="020B0503020204020204" charset="-122"/>
+                <a:ea typeface="微软雅黑" panose="020B0503020204020204" charset="-122"/>
+                <a:cs typeface="Work Sans" pitchFamily="34" charset="-120"/>
+              </a:rPr>
+              <a:t>Reflection, GenAI Usage, and Future Work</a:t>
+            </a:r>
+            <a:endParaRPr lang="en-US" sz="1780" dirty="0">
+              <a:latin typeface="微软雅黑" panose="020B0503020204020204" charset="-122"/>
+              <a:ea typeface="微软雅黑" panose="020B0503020204020204" charset="-122"/>
+            </a:endParaRPr>
+          </a:p>
+        </p:txBody>
+      </p:sp>
+      <p:sp>
+        <p:nvSpPr>
+          <p:cNvPr id="5" name="Text 3"/>
+          <p:cNvSpPr/>
+          <p:nvPr/>
+        </p:nvSpPr>
+        <p:spPr>
+          <a:xfrm>
+            <a:off x="186055" y="4805680"/>
+            <a:ext cx="2352040" cy="304800"/>
+          </a:xfrm>
+          <a:prstGeom prst="rect">
+            <a:avLst/>
+          </a:prstGeom>
+          <a:noFill/>
+        </p:spPr>
+        <p:txBody>
+          <a:bodyPr wrap="square" lIns="0" tIns="0" rIns="0" bIns="0" rtlCol="0" anchor="ctr"/>
+          <a:lstStyle/>
+          <a:p>
+            <a:pPr marL="0" indent="0" algn="l">
+              <a:lnSpc>
+                <a:spcPts val="2280"/>
+              </a:lnSpc>
+              <a:buNone/>
+            </a:pPr>
+            <a:r>
+              <a:rPr lang="en-US" sz="1425" kern="0" spc="-28" dirty="0">
+                <a:solidFill>
+                  <a:srgbClr val="000000">
+                    <a:alpha val="99000"/>
+                  </a:srgbClr>
+                </a:solidFill>
                 <a:latin typeface="Work Sans" pitchFamily="34" charset="0"/>
                 <a:ea typeface="Work Sans" pitchFamily="34" charset="-122"/>
                 <a:cs typeface="Work Sans" pitchFamily="34" charset="-120"/>
@@ -4678,7 +4228,7 @@
         <p:spPr>
           <a:xfrm>
             <a:off x="190500" y="142875"/>
-            <a:ext cx="6548120" cy="114300"/>
+            <a:ext cx="5238750" cy="114300"/>
           </a:xfrm>
           <a:prstGeom prst="rect">
             <a:avLst/>
@@ -4714,7 +4264,7 @@
       </p:sp>
       <p:sp>
         <p:nvSpPr>
-          <p:cNvPr id="13" name="Text 11"/>
+          <p:cNvPr id="8" name="Text 6"/>
           <p:cNvSpPr/>
           <p:nvPr>
             <p:custDataLst>
@@ -4724,7 +4274,145 @@
         </p:nvSpPr>
         <p:spPr>
           <a:xfrm>
-            <a:off x="6829425" y="1171575"/>
+            <a:off x="171450" y="1019175"/>
+            <a:ext cx="581025" cy="581025"/>
+          </a:xfrm>
+          <a:prstGeom prst="ellipse">
+            <a:avLst/>
+          </a:prstGeom>
+          <a:solidFill>
+            <a:srgbClr val="DCDBCE"/>
+          </a:solidFill>
+          <a:ln w="9049">
+            <a:solidFill>
+              <a:srgbClr val="000000"/>
+            </a:solidFill>
+          </a:ln>
+        </p:spPr>
+        <p:txBody>
+          <a:bodyPr wrap="square" rtlCol="0" anchor="ctr"/>
+          <a:lstStyle/>
+          <a:p>
+            <a:pPr marL="0" indent="0">
+              <a:buNone/>
+            </a:pPr>
+            <a:r>
+              <a:rPr lang="en-US" dirty="0">
+                <a:solidFill>
+                  <a:srgbClr val="000000"/>
+                </a:solidFill>
+              </a:rPr>
+              <a:t>A</a:t>
+            </a:r>
+            <a:endParaRPr lang="en-US" dirty="0"/>
+          </a:p>
+        </p:txBody>
+      </p:sp>
+      <p:sp>
+        <p:nvSpPr>
+          <p:cNvPr id="9" name="Text 7"/>
+          <p:cNvSpPr/>
+          <p:nvPr>
+            <p:custDataLst>
+              <p:tags r:id="rId2"/>
+            </p:custDataLst>
+          </p:nvPr>
+        </p:nvSpPr>
+        <p:spPr>
+          <a:xfrm>
+            <a:off x="3157538" y="1019175"/>
+            <a:ext cx="581025" cy="581025"/>
+          </a:xfrm>
+          <a:prstGeom prst="ellipse">
+            <a:avLst/>
+          </a:prstGeom>
+          <a:solidFill>
+            <a:srgbClr val="DCDBCE"/>
+          </a:solidFill>
+          <a:ln w="9049">
+            <a:solidFill>
+              <a:srgbClr val="000000"/>
+            </a:solidFill>
+          </a:ln>
+        </p:spPr>
+        <p:txBody>
+          <a:bodyPr wrap="square" rtlCol="0" anchor="ctr"/>
+          <a:lstStyle/>
+          <a:p>
+            <a:pPr marL="0" indent="0">
+              <a:buNone/>
+            </a:pPr>
+            <a:r>
+              <a:rPr lang="en-US" dirty="0">
+                <a:solidFill>
+                  <a:srgbClr val="000000"/>
+                </a:solidFill>
+              </a:rPr>
+              <a:t>B</a:t>
+            </a:r>
+            <a:endParaRPr lang="en-US" dirty="0"/>
+          </a:p>
+        </p:txBody>
+      </p:sp>
+      <p:sp>
+        <p:nvSpPr>
+          <p:cNvPr id="10" name="Text 8"/>
+          <p:cNvSpPr/>
+          <p:nvPr>
+            <p:custDataLst>
+              <p:tags r:id="rId3"/>
+            </p:custDataLst>
+          </p:nvPr>
+        </p:nvSpPr>
+        <p:spPr>
+          <a:xfrm>
+            <a:off x="6138863" y="1019175"/>
+            <a:ext cx="581025" cy="581025"/>
+          </a:xfrm>
+          <a:prstGeom prst="ellipse">
+            <a:avLst/>
+          </a:prstGeom>
+          <a:solidFill>
+            <a:srgbClr val="DCDBCE"/>
+          </a:solidFill>
+          <a:ln w="9049">
+            <a:solidFill>
+              <a:srgbClr val="000000"/>
+            </a:solidFill>
+          </a:ln>
+        </p:spPr>
+        <p:txBody>
+          <a:bodyPr wrap="square" rtlCol="0" anchor="ctr"/>
+          <a:lstStyle/>
+          <a:p>
+            <a:pPr marL="0" indent="0">
+              <a:buNone/>
+            </a:pPr>
+            <a:r>
+              <a:rPr lang="en-US" dirty="0">
+                <a:solidFill>
+                  <a:srgbClr val="000000"/>
+                </a:solidFill>
+              </a:rPr>
+              <a:t>C</a:t>
+            </a:r>
+            <a:endParaRPr lang="en-US" dirty="0"/>
+          </a:p>
+        </p:txBody>
+      </p:sp>
+      <p:sp>
+        <p:nvSpPr>
+          <p:cNvPr id="11" name="Text 9"/>
+          <p:cNvSpPr/>
+          <p:nvPr>
+            <p:custDataLst>
+              <p:tags r:id="rId4"/>
+            </p:custDataLst>
+          </p:nvPr>
+        </p:nvSpPr>
+        <p:spPr>
+          <a:xfrm>
+            <a:off x="866775" y="1171575"/>
             <a:ext cx="2290763" cy="276225"/>
           </a:xfrm>
           <a:prstGeom prst="rect">
@@ -4742,6 +4430,19 @@
               </a:lnSpc>
               <a:buNone/>
             </a:pPr>
+            <a:r>
+              <a:rPr lang="en-US" sz="1425" kern="0" spc="-28" dirty="0">
+                <a:solidFill>
+                  <a:srgbClr val="000000">
+                    <a:alpha val="99000"/>
+                  </a:srgbClr>
+                </a:solidFill>
+                <a:latin typeface="微软雅黑" panose="020B0503020204020204" charset="-122"/>
+                <a:ea typeface="微软雅黑" panose="020B0503020204020204" charset="-122"/>
+                <a:cs typeface="Work Sans" pitchFamily="34" charset="-120"/>
+              </a:rPr>
+              <a:t> Reflection</a:t>
+            </a:r>
             <a:endParaRPr lang="en-US" sz="1425" dirty="0">
               <a:latin typeface="微软雅黑" panose="020B0503020204020204" charset="-122"/>
               <a:ea typeface="微软雅黑" panose="020B0503020204020204" charset="-122"/>
@@ -4751,14 +4452,743 @@
       </p:sp>
       <p:sp>
         <p:nvSpPr>
+          <p:cNvPr id="12" name="Text 10"/>
+          <p:cNvSpPr/>
+          <p:nvPr>
+            <p:custDataLst>
+              <p:tags r:id="rId5"/>
+            </p:custDataLst>
+          </p:nvPr>
+        </p:nvSpPr>
+        <p:spPr>
+          <a:xfrm>
+            <a:off x="3848100" y="1171575"/>
+            <a:ext cx="2290763" cy="276225"/>
+          </a:xfrm>
+          <a:prstGeom prst="rect">
+            <a:avLst/>
+          </a:prstGeom>
+          <a:noFill/>
+        </p:spPr>
+        <p:txBody>
+          <a:bodyPr wrap="square" lIns="0" tIns="0" rIns="0" bIns="0" rtlCol="0" anchor="ctr"/>
+          <a:lstStyle/>
+          <a:p>
+            <a:pPr marL="0" indent="0" algn="l">
+              <a:lnSpc>
+                <a:spcPts val="2060"/>
+              </a:lnSpc>
+              <a:buNone/>
+            </a:pPr>
+            <a:r>
+              <a:rPr lang="en-US" sz="1425" kern="0" spc="-28" dirty="0">
+                <a:solidFill>
+                  <a:srgbClr val="000000">
+                    <a:alpha val="99000"/>
+                  </a:srgbClr>
+                </a:solidFill>
+                <a:latin typeface="微软雅黑" panose="020B0503020204020204" charset="-122"/>
+                <a:ea typeface="微软雅黑" panose="020B0503020204020204" charset="-122"/>
+                <a:cs typeface="Work Sans" pitchFamily="34" charset="-120"/>
+              </a:rPr>
+              <a:t>GenAI Usage</a:t>
+            </a:r>
+            <a:endParaRPr lang="en-US" sz="1425" dirty="0">
+              <a:latin typeface="微软雅黑" panose="020B0503020204020204" charset="-122"/>
+              <a:ea typeface="微软雅黑" panose="020B0503020204020204" charset="-122"/>
+            </a:endParaRPr>
+          </a:p>
+        </p:txBody>
+      </p:sp>
+      <p:sp>
+        <p:nvSpPr>
+          <p:cNvPr id="13" name="Text 11"/>
+          <p:cNvSpPr/>
+          <p:nvPr>
+            <p:custDataLst>
+              <p:tags r:id="rId6"/>
+            </p:custDataLst>
+          </p:nvPr>
+        </p:nvSpPr>
+        <p:spPr>
+          <a:xfrm>
+            <a:off x="6829425" y="1171575"/>
+            <a:ext cx="2290763" cy="276225"/>
+          </a:xfrm>
+          <a:prstGeom prst="rect">
+            <a:avLst/>
+          </a:prstGeom>
+          <a:noFill/>
+        </p:spPr>
+        <p:txBody>
+          <a:bodyPr wrap="square" lIns="0" tIns="0" rIns="0" bIns="0" rtlCol="0" anchor="ctr"/>
+          <a:lstStyle/>
+          <a:p>
+            <a:pPr marL="0" indent="0" algn="l">
+              <a:lnSpc>
+                <a:spcPts val="2060"/>
+              </a:lnSpc>
+              <a:buNone/>
+            </a:pPr>
+            <a:r>
+              <a:rPr lang="en-US" sz="1425" kern="0" spc="-28" dirty="0">
+                <a:solidFill>
+                  <a:srgbClr val="000000">
+                    <a:alpha val="99000"/>
+                  </a:srgbClr>
+                </a:solidFill>
+                <a:latin typeface="微软雅黑" panose="020B0503020204020204" charset="-122"/>
+                <a:ea typeface="微软雅黑" panose="020B0503020204020204" charset="-122"/>
+                <a:cs typeface="Work Sans" pitchFamily="34" charset="-120"/>
+              </a:rPr>
+              <a:t>Future Work</a:t>
+            </a:r>
+            <a:endParaRPr lang="en-US" sz="1425" dirty="0">
+              <a:latin typeface="微软雅黑" panose="020B0503020204020204" charset="-122"/>
+              <a:ea typeface="微软雅黑" panose="020B0503020204020204" charset="-122"/>
+            </a:endParaRPr>
+          </a:p>
+        </p:txBody>
+      </p:sp>
+      <p:sp>
+        <p:nvSpPr>
+          <p:cNvPr id="14" name="Text 12"/>
+          <p:cNvSpPr/>
+          <p:nvPr>
+            <p:custDataLst>
+              <p:tags r:id="rId7"/>
+            </p:custDataLst>
+          </p:nvPr>
+        </p:nvSpPr>
+        <p:spPr>
+          <a:xfrm>
+            <a:off x="85725" y="1728470"/>
+            <a:ext cx="2914015" cy="1652905"/>
+          </a:xfrm>
+          <a:prstGeom prst="rect">
+            <a:avLst/>
+          </a:prstGeom>
+          <a:noFill/>
+        </p:spPr>
+        <p:txBody>
+          <a:bodyPr wrap="square" lIns="0" tIns="0" rIns="0" bIns="0" rtlCol="0" anchor="ctr"/>
+          <a:lstStyle/>
+          <a:p>
+            <a:pPr marL="342900" indent="-342900" algn="l">
+              <a:lnSpc>
+                <a:spcPts val="2060"/>
+              </a:lnSpc>
+              <a:buSzPct val="100000"/>
+              <a:buChar char="•"/>
+            </a:pPr>
+            <a:r>
+              <a:rPr lang="en-US" sz="855" kern="0" spc="-17" dirty="0">
+                <a:solidFill>
+                  <a:srgbClr val="000000">
+                    <a:alpha val="99000"/>
+                  </a:srgbClr>
+                </a:solidFill>
+                <a:latin typeface="微软雅黑" panose="020B0503020204020204" charset="-122"/>
+                <a:ea typeface="微软雅黑" panose="020B0503020204020204" charset="-122"/>
+                <a:cs typeface="Work Sans" pitchFamily="34" charset="-120"/>
+              </a:rPr>
+              <a:t>Learned practical REST API design and data modelling</a:t>
+            </a:r>
+            <a:endParaRPr lang="en-US" sz="855" dirty="0">
+              <a:latin typeface="微软雅黑" panose="020B0503020204020204" charset="-122"/>
+              <a:ea typeface="微软雅黑" panose="020B0503020204020204" charset="-122"/>
+            </a:endParaRPr>
+          </a:p>
+          <a:p>
+            <a:pPr marL="342900" indent="-342900" algn="l">
+              <a:lnSpc>
+                <a:spcPts val="2060"/>
+              </a:lnSpc>
+              <a:buSzPct val="100000"/>
+              <a:buChar char="•"/>
+            </a:pPr>
+            <a:r>
+              <a:rPr lang="en-US" sz="855" kern="0" spc="-17" dirty="0">
+                <a:solidFill>
+                  <a:srgbClr val="000000">
+                    <a:alpha val="99000"/>
+                  </a:srgbClr>
+                </a:solidFill>
+                <a:latin typeface="微软雅黑" panose="020B0503020204020204" charset="-122"/>
+                <a:ea typeface="微软雅黑" panose="020B0503020204020204" charset="-122"/>
+                <a:cs typeface="Work Sans" pitchFamily="34" charset="-120"/>
+              </a:rPr>
+              <a:t>Improved testing, debugging, and project structuring skills</a:t>
+            </a:r>
+            <a:endParaRPr lang="en-US" sz="855" dirty="0">
+              <a:latin typeface="微软雅黑" panose="020B0503020204020204" charset="-122"/>
+              <a:ea typeface="微软雅黑" panose="020B0503020204020204" charset="-122"/>
+            </a:endParaRPr>
+          </a:p>
+          <a:p>
+            <a:pPr marL="342900" indent="-342900" algn="l">
+              <a:lnSpc>
+                <a:spcPts val="2060"/>
+              </a:lnSpc>
+              <a:buSzPct val="100000"/>
+              <a:buChar char="•"/>
+            </a:pPr>
+            <a:r>
+              <a:rPr lang="en-US" sz="855" kern="0" spc="-17" dirty="0">
+                <a:solidFill>
+                  <a:srgbClr val="000000">
+                    <a:alpha val="99000"/>
+                  </a:srgbClr>
+                </a:solidFill>
+                <a:latin typeface="微软雅黑" panose="020B0503020204020204" charset="-122"/>
+                <a:ea typeface="微软雅黑" panose="020B0503020204020204" charset="-122"/>
+                <a:cs typeface="Work Sans" pitchFamily="34" charset="-120"/>
+              </a:rPr>
+              <a:t>Better understood how to turn raw datasets into usable services</a:t>
+            </a:r>
+            <a:endParaRPr lang="en-US" sz="855" dirty="0">
+              <a:latin typeface="微软雅黑" panose="020B0503020204020204" charset="-122"/>
+              <a:ea typeface="微软雅黑" panose="020B0503020204020204" charset="-122"/>
+            </a:endParaRPr>
+          </a:p>
+        </p:txBody>
+      </p:sp>
+      <p:sp>
+        <p:nvSpPr>
+          <p:cNvPr id="15" name="Text 13"/>
+          <p:cNvSpPr/>
+          <p:nvPr>
+            <p:custDataLst>
+              <p:tags r:id="rId8"/>
+            </p:custDataLst>
+          </p:nvPr>
+        </p:nvSpPr>
+        <p:spPr>
+          <a:xfrm>
+            <a:off x="6138863" y="1614488"/>
+            <a:ext cx="2814638" cy="1652588"/>
+          </a:xfrm>
+          <a:prstGeom prst="rect">
+            <a:avLst/>
+          </a:prstGeom>
+          <a:noFill/>
+        </p:spPr>
+        <p:txBody>
+          <a:bodyPr wrap="square" lIns="0" tIns="0" rIns="0" bIns="0" rtlCol="0" anchor="ctr"/>
+          <a:lstStyle/>
+          <a:p>
+            <a:pPr marL="342900" indent="-342900" algn="l">
+              <a:lnSpc>
+                <a:spcPts val="2060"/>
+              </a:lnSpc>
+              <a:buSzPct val="100000"/>
+              <a:buChar char="•"/>
+            </a:pPr>
+            <a:r>
+              <a:rPr lang="en-US" sz="855" kern="0" spc="-17" dirty="0">
+                <a:solidFill>
+                  <a:srgbClr val="000000">
+                    <a:alpha val="99000"/>
+                  </a:srgbClr>
+                </a:solidFill>
+                <a:latin typeface="微软雅黑" panose="020B0503020204020204" charset="-122"/>
+                <a:ea typeface="微软雅黑" panose="020B0503020204020204" charset="-122"/>
+                <a:cs typeface="Work Sans" pitchFamily="34" charset="-120"/>
+              </a:rPr>
+              <a:t>Add richer analytics and comparison endpoints</a:t>
+            </a:r>
+            <a:endParaRPr lang="en-US" sz="855" dirty="0">
+              <a:latin typeface="微软雅黑" panose="020B0503020204020204" charset="-122"/>
+              <a:ea typeface="微软雅黑" panose="020B0503020204020204" charset="-122"/>
+            </a:endParaRPr>
+          </a:p>
+          <a:p>
+            <a:pPr marL="342900" indent="-342900" algn="l">
+              <a:lnSpc>
+                <a:spcPts val="2060"/>
+              </a:lnSpc>
+              <a:buSzPct val="100000"/>
+              <a:buChar char="•"/>
+            </a:pPr>
+            <a:r>
+              <a:rPr lang="en-US" sz="855" kern="0" spc="-17" dirty="0">
+                <a:solidFill>
+                  <a:srgbClr val="000000">
+                    <a:alpha val="99000"/>
+                  </a:srgbClr>
+                </a:solidFill>
+                <a:latin typeface="微软雅黑" panose="020B0503020204020204" charset="-122"/>
+                <a:ea typeface="微软雅黑" panose="020B0503020204020204" charset="-122"/>
+                <a:cs typeface="Work Sans" pitchFamily="34" charset="-120"/>
+              </a:rPr>
+              <a:t>Introduce role-based authorization and stronger security controls</a:t>
+            </a:r>
+            <a:endParaRPr lang="en-US" sz="855" dirty="0">
+              <a:latin typeface="微软雅黑" panose="020B0503020204020204" charset="-122"/>
+              <a:ea typeface="微软雅黑" panose="020B0503020204020204" charset="-122"/>
+            </a:endParaRPr>
+          </a:p>
+          <a:p>
+            <a:pPr marL="342900" indent="-342900" algn="l">
+              <a:lnSpc>
+                <a:spcPts val="2060"/>
+              </a:lnSpc>
+              <a:buSzPct val="100000"/>
+              <a:buChar char="•"/>
+            </a:pPr>
+            <a:r>
+              <a:rPr lang="en-US" sz="855" kern="0" spc="-17" dirty="0">
+                <a:solidFill>
+                  <a:srgbClr val="000000">
+                    <a:alpha val="99000"/>
+                  </a:srgbClr>
+                </a:solidFill>
+                <a:latin typeface="微软雅黑" panose="020B0503020204020204" charset="-122"/>
+                <a:ea typeface="微软雅黑" panose="020B0503020204020204" charset="-122"/>
+                <a:cs typeface="Work Sans" pitchFamily="34" charset="-120"/>
+              </a:rPr>
+              <a:t>Move to cloud database and more production-ready deployment</a:t>
+            </a:r>
+            <a:endParaRPr lang="en-US" sz="855" dirty="0">
+              <a:latin typeface="微软雅黑" panose="020B0503020204020204" charset="-122"/>
+              <a:ea typeface="微软雅黑" panose="020B0503020204020204" charset="-122"/>
+            </a:endParaRPr>
+          </a:p>
+        </p:txBody>
+      </p:sp>
+      <p:sp>
+        <p:nvSpPr>
+          <p:cNvPr id="16" name="Text 14"/>
+          <p:cNvSpPr/>
+          <p:nvPr>
+            <p:custDataLst>
+              <p:tags r:id="rId9"/>
+            </p:custDataLst>
+          </p:nvPr>
+        </p:nvSpPr>
+        <p:spPr>
+          <a:xfrm>
+            <a:off x="3157538" y="1728153"/>
+            <a:ext cx="2628900" cy="1652588"/>
+          </a:xfrm>
+          <a:prstGeom prst="rect">
+            <a:avLst/>
+          </a:prstGeom>
+          <a:noFill/>
+        </p:spPr>
+        <p:txBody>
+          <a:bodyPr wrap="square" lIns="0" tIns="0" rIns="0" bIns="0" rtlCol="0" anchor="ctr"/>
+          <a:lstStyle/>
+          <a:p>
+            <a:pPr marL="342900" indent="-342900" algn="l">
+              <a:lnSpc>
+                <a:spcPts val="2060"/>
+              </a:lnSpc>
+              <a:buSzPct val="100000"/>
+              <a:buChar char="•"/>
+            </a:pPr>
+            <a:r>
+              <a:rPr lang="en-US" sz="855" kern="0" spc="-17" dirty="0">
+                <a:solidFill>
+                  <a:srgbClr val="000000">
+                    <a:alpha val="99000"/>
+                  </a:srgbClr>
+                </a:solidFill>
+                <a:latin typeface="微软雅黑" panose="020B0503020204020204" charset="-122"/>
+                <a:ea typeface="微软雅黑" panose="020B0503020204020204" charset="-122"/>
+                <a:cs typeface="Work Sans" pitchFamily="34" charset="-120"/>
+              </a:rPr>
+              <a:t>Used GenAI for planning, debugging, and refining design ideas</a:t>
+            </a:r>
+            <a:endParaRPr lang="en-US" sz="855" dirty="0">
+              <a:latin typeface="微软雅黑" panose="020B0503020204020204" charset="-122"/>
+              <a:ea typeface="微软雅黑" panose="020B0503020204020204" charset="-122"/>
+            </a:endParaRPr>
+          </a:p>
+          <a:p>
+            <a:pPr marL="342900" indent="-342900" algn="l">
+              <a:lnSpc>
+                <a:spcPts val="2060"/>
+              </a:lnSpc>
+              <a:buSzPct val="100000"/>
+              <a:buChar char="•"/>
+            </a:pPr>
+            <a:r>
+              <a:rPr lang="en-US" sz="855" kern="0" spc="-17" dirty="0">
+                <a:solidFill>
+                  <a:srgbClr val="000000">
+                    <a:alpha val="99000"/>
+                  </a:srgbClr>
+                </a:solidFill>
+                <a:latin typeface="微软雅黑" panose="020B0503020204020204" charset="-122"/>
+                <a:ea typeface="微软雅黑" panose="020B0503020204020204" charset="-122"/>
+                <a:cs typeface="Work Sans" pitchFamily="34" charset="-120"/>
+              </a:rPr>
+              <a:t>Outputs were reviewed, adapted, and validated before use</a:t>
+            </a:r>
+            <a:endParaRPr lang="en-US" sz="855" dirty="0">
+              <a:latin typeface="微软雅黑" panose="020B0503020204020204" charset="-122"/>
+              <a:ea typeface="微软雅黑" panose="020B0503020204020204" charset="-122"/>
+            </a:endParaRPr>
+          </a:p>
+          <a:p>
+            <a:pPr marL="342900" indent="-342900" algn="l">
+              <a:lnSpc>
+                <a:spcPts val="2060"/>
+              </a:lnSpc>
+              <a:buSzPct val="100000"/>
+              <a:buChar char="•"/>
+            </a:pPr>
+            <a:r>
+              <a:rPr lang="en-US" sz="855" kern="0" spc="-17" dirty="0">
+                <a:solidFill>
+                  <a:srgbClr val="000000">
+                    <a:alpha val="99000"/>
+                  </a:srgbClr>
+                </a:solidFill>
+                <a:latin typeface="微软雅黑" panose="020B0503020204020204" charset="-122"/>
+                <a:ea typeface="微软雅黑" panose="020B0503020204020204" charset="-122"/>
+                <a:cs typeface="Work Sans" pitchFamily="34" charset="-120"/>
+              </a:rPr>
+              <a:t>Usage was documented in the report with supporting evidence</a:t>
+            </a:r>
+            <a:endParaRPr lang="en-US" sz="855" dirty="0">
+              <a:latin typeface="微软雅黑" panose="020B0503020204020204" charset="-122"/>
+              <a:ea typeface="微软雅黑" panose="020B0503020204020204" charset="-122"/>
+            </a:endParaRPr>
+          </a:p>
+        </p:txBody>
+      </p:sp>
+      <p:pic>
+        <p:nvPicPr>
+          <p:cNvPr id="17" name="Image 0" descr="preencoded.png"/>
+          <p:cNvPicPr>
+            <a:picLocks noChangeAspect="1"/>
+          </p:cNvPicPr>
+          <p:nvPr/>
+        </p:nvPicPr>
+        <p:blipFill>
+          <a:blip r:embed="rId10"/>
+          <a:srcRect/>
+          <a:stretch>
+            <a:fillRect/>
+          </a:stretch>
+        </p:blipFill>
+        <p:spPr>
+          <a:xfrm>
+            <a:off x="128588" y="3581083"/>
+            <a:ext cx="2681288" cy="638175"/>
+          </a:xfrm>
+          <a:prstGeom prst="rect">
+            <a:avLst/>
+          </a:prstGeom>
+        </p:spPr>
+      </p:pic>
+      <p:pic>
+        <p:nvPicPr>
+          <p:cNvPr id="18" name="Image 1" descr="preencoded.png"/>
+          <p:cNvPicPr>
+            <a:picLocks noChangeAspect="1"/>
+          </p:cNvPicPr>
+          <p:nvPr/>
+        </p:nvPicPr>
+        <p:blipFill>
+          <a:blip r:embed="rId11"/>
+          <a:srcRect/>
+          <a:stretch>
+            <a:fillRect/>
+          </a:stretch>
+        </p:blipFill>
+        <p:spPr>
+          <a:xfrm>
+            <a:off x="3343275" y="3434080"/>
+            <a:ext cx="2085975" cy="1266825"/>
+          </a:xfrm>
+          <a:prstGeom prst="rect">
+            <a:avLst/>
+          </a:prstGeom>
+        </p:spPr>
+      </p:pic>
+      <p:pic>
+        <p:nvPicPr>
+          <p:cNvPr id="19" name="Image 2" descr="preencoded.png"/>
+          <p:cNvPicPr>
+            <a:picLocks noChangeAspect="1"/>
+          </p:cNvPicPr>
+          <p:nvPr/>
+        </p:nvPicPr>
+        <p:blipFill>
+          <a:blip r:embed="rId12"/>
+          <a:srcRect/>
+          <a:stretch>
+            <a:fillRect/>
+          </a:stretch>
+        </p:blipFill>
+        <p:spPr>
+          <a:xfrm>
+            <a:off x="6429375" y="3381375"/>
+            <a:ext cx="2138363" cy="471488"/>
+          </a:xfrm>
+          <a:prstGeom prst="rect">
+            <a:avLst/>
+          </a:prstGeom>
+        </p:spPr>
+      </p:pic>
+    </p:spTree>
+  </p:cSld>
+  <p:clrMapOvr>
+    <a:masterClrMapping/>
+  </p:clrMapOvr>
+</p:sld>
+</file>
+
+<file path=ppt/slides/slide15.xml><?xml version="1.0" encoding="utf-8"?>
+<p:sld xmlns:a="http://schemas.openxmlformats.org/drawingml/2006/main" xmlns:r="http://schemas.openxmlformats.org/officeDocument/2006/relationships" xmlns:p="http://schemas.openxmlformats.org/presentationml/2006/main">
+  <p:cSld>
+    <p:bg>
+      <p:bgPr>
+        <a:solidFill>
+          <a:srgbClr val="DCDBCE"/>
+        </a:solidFill>
+        <a:effectLst/>
+      </p:bgPr>
+    </p:bg>
+    <p:spTree>
+      <p:nvGrpSpPr>
+        <p:cNvPr id="1" name=""/>
+        <p:cNvGrpSpPr/>
+        <p:nvPr/>
+      </p:nvGrpSpPr>
+      <p:grpSpPr>
+        <a:xfrm>
+          <a:off x="0" y="0"/>
+          <a:ext cx="0" cy="0"/>
+          <a:chOff x="0" y="0"/>
+          <a:chExt cx="0" cy="0"/>
+        </a:xfrm>
+      </p:grpSpPr>
+      <p:sp>
+        <p:nvSpPr>
+          <p:cNvPr id="2" name="Shape 0"/>
+          <p:cNvSpPr/>
+          <p:nvPr/>
+        </p:nvSpPr>
+        <p:spPr>
+          <a:xfrm rot="5400000">
+            <a:off x="-1531144" y="2540794"/>
+            <a:ext cx="3043238" cy="0"/>
+          </a:xfrm>
+          <a:prstGeom prst="line">
+            <a:avLst/>
+          </a:prstGeom>
+          <a:noFill/>
+          <a:ln w="4524">
+            <a:solidFill>
+              <a:srgbClr val="000000"/>
+            </a:solidFill>
+            <a:prstDash val="solid"/>
+          </a:ln>
+        </p:spPr>
+      </p:sp>
+      <p:sp>
+        <p:nvSpPr>
+          <p:cNvPr id="3" name="Shape 1"/>
+          <p:cNvSpPr/>
+          <p:nvPr/>
+        </p:nvSpPr>
+        <p:spPr>
+          <a:xfrm rot="5400000">
+            <a:off x="7872413" y="3300413"/>
+            <a:ext cx="2543175" cy="0"/>
+          </a:xfrm>
+          <a:prstGeom prst="line">
+            <a:avLst/>
+          </a:prstGeom>
+          <a:noFill/>
+          <a:ln w="4524">
+            <a:solidFill>
+              <a:srgbClr val="000000"/>
+            </a:solidFill>
+            <a:prstDash val="solid"/>
+          </a:ln>
+        </p:spPr>
+      </p:sp>
+      <p:sp>
+        <p:nvSpPr>
+          <p:cNvPr id="5" name="Text 3"/>
+          <p:cNvSpPr/>
+          <p:nvPr/>
+        </p:nvSpPr>
+        <p:spPr>
+          <a:xfrm>
+            <a:off x="186055" y="4805680"/>
+            <a:ext cx="2352040" cy="304800"/>
+          </a:xfrm>
+          <a:prstGeom prst="rect">
+            <a:avLst/>
+          </a:prstGeom>
+          <a:noFill/>
+        </p:spPr>
+        <p:txBody>
+          <a:bodyPr wrap="square" lIns="0" tIns="0" rIns="0" bIns="0" rtlCol="0" anchor="ctr"/>
+          <a:lstStyle/>
+          <a:p>
+            <a:pPr marL="0" indent="0" algn="l">
+              <a:lnSpc>
+                <a:spcPts val="2280"/>
+              </a:lnSpc>
+              <a:buNone/>
+            </a:pPr>
+            <a:r>
+              <a:rPr lang="en-US" sz="1425" kern="0" spc="-28" dirty="0">
+                <a:solidFill>
+                  <a:srgbClr val="000000">
+                    <a:alpha val="99000"/>
+                  </a:srgbClr>
+                </a:solidFill>
+                <a:latin typeface="Work Sans" pitchFamily="34" charset="0"/>
+                <a:ea typeface="Work Sans" pitchFamily="34" charset="-122"/>
+                <a:cs typeface="Work Sans" pitchFamily="34" charset="-120"/>
+              </a:rPr>
+              <a:t>Shirui Zhao</a:t>
+            </a:r>
+            <a:endParaRPr lang="en-US" sz="1425" dirty="0"/>
+          </a:p>
+        </p:txBody>
+      </p:sp>
+      <p:sp>
+        <p:nvSpPr>
+          <p:cNvPr id="6" name="Text 4"/>
+          <p:cNvSpPr/>
+          <p:nvPr/>
+        </p:nvSpPr>
+        <p:spPr>
+          <a:xfrm>
+            <a:off x="7652385" y="4910455"/>
+            <a:ext cx="1301115" cy="114300"/>
+          </a:xfrm>
+          <a:prstGeom prst="rect">
+            <a:avLst/>
+          </a:prstGeom>
+          <a:noFill/>
+        </p:spPr>
+        <p:txBody>
+          <a:bodyPr wrap="square" lIns="0" tIns="0" rIns="0" bIns="0" rtlCol="0" anchor="ctr"/>
+          <a:lstStyle/>
+          <a:p>
+            <a:pPr marL="0" indent="0" algn="r">
+              <a:lnSpc>
+                <a:spcPts val="865"/>
+              </a:lnSpc>
+              <a:buNone/>
+            </a:pPr>
+            <a:r>
+              <a:rPr lang="en-US" sz="785" kern="0" spc="78" dirty="0">
+                <a:solidFill>
+                  <a:srgbClr val="000000">
+                    <a:alpha val="99000"/>
+                  </a:srgbClr>
+                </a:solidFill>
+                <a:latin typeface="Cutive Mono" pitchFamily="34" charset="0"/>
+                <a:ea typeface="Cutive Mono" pitchFamily="34" charset="-122"/>
+                <a:cs typeface="Cutive Mono" pitchFamily="34" charset="-120"/>
+              </a:rPr>
+              <a:t>2026-03-12</a:t>
+            </a:r>
+            <a:endParaRPr lang="en-US" sz="785" dirty="0"/>
+          </a:p>
+        </p:txBody>
+      </p:sp>
+      <p:sp>
+        <p:nvSpPr>
+          <p:cNvPr id="7" name="Text 5"/>
+          <p:cNvSpPr/>
+          <p:nvPr/>
+        </p:nvSpPr>
+        <p:spPr>
+          <a:xfrm>
+            <a:off x="190500" y="142875"/>
+            <a:ext cx="6548120" cy="114300"/>
+          </a:xfrm>
+          <a:prstGeom prst="rect">
+            <a:avLst/>
+          </a:prstGeom>
+          <a:noFill/>
+        </p:spPr>
+        <p:txBody>
+          <a:bodyPr wrap="square" lIns="0" tIns="0" rIns="0" bIns="0" rtlCol="0" anchor="ctr"/>
+          <a:lstStyle/>
+          <a:p>
+            <a:pPr marL="0" indent="0" algn="l">
+              <a:lnSpc>
+                <a:spcPts val="865"/>
+              </a:lnSpc>
+              <a:buNone/>
+            </a:pPr>
+            <a:r>
+              <a:rPr lang="en-US" sz="785" kern="0" spc="78" dirty="0">
+                <a:solidFill>
+                  <a:srgbClr val="000000">
+                    <a:alpha val="99000"/>
+                  </a:srgbClr>
+                </a:solidFill>
+                <a:latin typeface="Cutive Mono" pitchFamily="34" charset="0"/>
+                <a:ea typeface="Cutive Mono" pitchFamily="34" charset="-122"/>
+                <a:cs typeface="Cutive Mono" pitchFamily="34" charset="-120"/>
+              </a:rPr>
+              <a:t>COMP3011 COURSEWORK 1 – INDIVIDUAL WEB SERVICES API DEVELOPMENT PROJECT</a:t>
+            </a:r>
+            <a:endParaRPr lang="en-US" sz="785" dirty="0"/>
+          </a:p>
+        </p:txBody>
+      </p:sp>
+      <p:sp>
+        <p:nvSpPr>
+          <p:cNvPr id="13" name="Text 11"/>
+          <p:cNvSpPr/>
+          <p:nvPr>
+            <p:custDataLst>
+              <p:tags r:id="rId1"/>
+            </p:custDataLst>
+          </p:nvPr>
+        </p:nvSpPr>
+        <p:spPr>
+          <a:xfrm>
+            <a:off x="6829425" y="1171575"/>
+            <a:ext cx="2290763" cy="276225"/>
+          </a:xfrm>
+          <a:prstGeom prst="rect">
+            <a:avLst/>
+          </a:prstGeom>
+          <a:noFill/>
+        </p:spPr>
+        <p:txBody>
+          <a:bodyPr wrap="square" lIns="0" tIns="0" rIns="0" bIns="0" rtlCol="0" anchor="ctr"/>
+          <a:lstStyle/>
+          <a:p>
+            <a:pPr marL="0" indent="0" algn="l">
+              <a:lnSpc>
+                <a:spcPts val="2060"/>
+              </a:lnSpc>
+              <a:buNone/>
+            </a:pPr>
+            <a:endParaRPr lang="en-US" sz="1425" dirty="0">
+              <a:latin typeface="微软雅黑" panose="020B0503020204020204" charset="-122"/>
+              <a:ea typeface="微软雅黑" panose="020B0503020204020204" charset="-122"/>
+            </a:endParaRPr>
+          </a:p>
+        </p:txBody>
+      </p:sp>
+      <p:sp>
+        <p:nvSpPr>
           <p:cNvPr id="20" name="文本框 19"/>
           <p:cNvSpPr txBox="1"/>
           <p:nvPr/>
         </p:nvSpPr>
         <p:spPr>
           <a:xfrm>
-            <a:off x="2283460" y="2279650"/>
-            <a:ext cx="4577080" cy="583565"/>
+            <a:off x="1803400" y="2279650"/>
+            <a:ext cx="5551805" cy="583565"/>
           </a:xfrm>
           <a:prstGeom prst="rect">
             <a:avLst/>
@@ -8024,7 +8454,7 @@
         </p:nvSpPr>
         <p:spPr>
           <a:xfrm>
-            <a:off x="185738" y="485775"/>
+            <a:off x="438150" y="638175"/>
             <a:ext cx="4738688" cy="304800"/>
           </a:xfrm>
           <a:prstGeom prst="rect">
@@ -8043,35 +8473,72 @@
               <a:buNone/>
             </a:pPr>
             <a:r>
-              <a:rPr lang="en-US" sz="1780" b="1" kern="0" spc="-36" dirty="0">
+              <a:rPr lang="en-US" altLang="zh-CN" sz="1780" b="1" dirty="0">
+                <a:latin typeface="微软雅黑" panose="020B0503020204020204" charset="-122"/>
+                <a:ea typeface="微软雅黑" panose="020B0503020204020204" charset="-122"/>
+              </a:rPr>
+              <a:t>Geographic Rent Explorer</a:t>
+            </a:r>
+            <a:endParaRPr lang="en-US" altLang="zh-CN" sz="1780" b="1" dirty="0">
+              <a:latin typeface="微软雅黑" panose="020B0503020204020204" charset="-122"/>
+              <a:ea typeface="微软雅黑" panose="020B0503020204020204" charset="-122"/>
+            </a:endParaRPr>
+          </a:p>
+        </p:txBody>
+      </p:sp>
+      <p:sp>
+        <p:nvSpPr>
+          <p:cNvPr id="5" name="Text 3"/>
+          <p:cNvSpPr/>
+          <p:nvPr/>
+        </p:nvSpPr>
+        <p:spPr>
+          <a:xfrm>
+            <a:off x="195580" y="4791075"/>
+            <a:ext cx="2776855" cy="304800"/>
+          </a:xfrm>
+          <a:prstGeom prst="rect">
+            <a:avLst/>
+          </a:prstGeom>
+          <a:noFill/>
+        </p:spPr>
+        <p:txBody>
+          <a:bodyPr wrap="square" lIns="0" tIns="0" rIns="0" bIns="0" rtlCol="0" anchor="ctr"/>
+          <a:lstStyle/>
+          <a:p>
+            <a:pPr marL="0" indent="0" algn="l">
+              <a:lnSpc>
+                <a:spcPts val="2280"/>
+              </a:lnSpc>
+              <a:buNone/>
+            </a:pPr>
+            <a:r>
+              <a:rPr lang="en-US" sz="1425" kern="0" spc="-28" dirty="0">
                 <a:solidFill>
                   <a:srgbClr val="000000">
                     <a:alpha val="99000"/>
                   </a:srgbClr>
                 </a:solidFill>
-                <a:latin typeface="微软雅黑" panose="020B0503020204020204" charset="-122"/>
-                <a:ea typeface="微软雅黑" panose="020B0503020204020204" charset="-122"/>
+                <a:latin typeface="Work Sans" pitchFamily="34" charset="0"/>
+                <a:ea typeface="Work Sans" pitchFamily="34" charset="-122"/>
                 <a:cs typeface="Work Sans" pitchFamily="34" charset="-120"/>
               </a:rPr>
-              <a:t>Testing, Deployment, and Deliverables</a:t>
-            </a:r>
-            <a:endParaRPr lang="en-US" sz="1780" dirty="0">
-              <a:latin typeface="微软雅黑" panose="020B0503020204020204" charset="-122"/>
-              <a:ea typeface="微软雅黑" panose="020B0503020204020204" charset="-122"/>
-            </a:endParaRPr>
-          </a:p>
-        </p:txBody>
-      </p:sp>
-      <p:sp>
-        <p:nvSpPr>
-          <p:cNvPr id="5" name="Text 3"/>
-          <p:cNvSpPr/>
-          <p:nvPr/>
-        </p:nvSpPr>
-        <p:spPr>
-          <a:xfrm>
-            <a:off x="186055" y="4805680"/>
-            <a:ext cx="2768600" cy="304800"/>
+              <a:t>Shirui Zhao</a:t>
+            </a:r>
+            <a:endParaRPr lang="en-US" sz="1425" dirty="0"/>
+          </a:p>
+        </p:txBody>
+      </p:sp>
+      <p:sp>
+        <p:nvSpPr>
+          <p:cNvPr id="6" name="Text 4"/>
+          <p:cNvSpPr/>
+          <p:nvPr/>
+        </p:nvSpPr>
+        <p:spPr>
+          <a:xfrm>
+            <a:off x="7231380" y="4886325"/>
+            <a:ext cx="1722120" cy="114300"/>
           </a:xfrm>
           <a:prstGeom prst="rect">
             <a:avLst/>
@@ -8082,39 +8549,39 @@
           <a:bodyPr wrap="square" lIns="0" tIns="0" rIns="0" bIns="0" rtlCol="0" anchor="ctr"/>
           <a:lstStyle/>
           <a:p>
-            <a:pPr marL="0" indent="0" algn="l">
-              <a:lnSpc>
-                <a:spcPts val="2280"/>
+            <a:pPr marL="0" indent="0" algn="r">
+              <a:lnSpc>
+                <a:spcPts val="865"/>
               </a:lnSpc>
               <a:buNone/>
             </a:pPr>
             <a:r>
-              <a:rPr lang="en-US" sz="1425" kern="0" spc="-28" dirty="0">
+              <a:rPr lang="en-US" sz="785" kern="0" spc="78" dirty="0">
                 <a:solidFill>
                   <a:srgbClr val="000000">
                     <a:alpha val="99000"/>
                   </a:srgbClr>
                 </a:solidFill>
-                <a:latin typeface="Work Sans" pitchFamily="34" charset="0"/>
-                <a:ea typeface="Work Sans" pitchFamily="34" charset="-122"/>
-                <a:cs typeface="Work Sans" pitchFamily="34" charset="-120"/>
-              </a:rPr>
-              <a:t>Shirui Zhao</a:t>
-            </a:r>
-            <a:endParaRPr lang="en-US" sz="1425" dirty="0"/>
-          </a:p>
-        </p:txBody>
-      </p:sp>
-      <p:sp>
-        <p:nvSpPr>
-          <p:cNvPr id="6" name="Text 4"/>
-          <p:cNvSpPr/>
-          <p:nvPr/>
-        </p:nvSpPr>
-        <p:spPr>
-          <a:xfrm>
-            <a:off x="6585585" y="4910455"/>
-            <a:ext cx="2367915" cy="114300"/>
+                <a:latin typeface="Cutive Mono" pitchFamily="34" charset="0"/>
+                <a:ea typeface="Cutive Mono" pitchFamily="34" charset="-122"/>
+                <a:cs typeface="Cutive Mono" pitchFamily="34" charset="-120"/>
+              </a:rPr>
+              <a:t>2026-03-12</a:t>
+            </a:r>
+            <a:endParaRPr lang="en-US" sz="785" dirty="0"/>
+          </a:p>
+        </p:txBody>
+      </p:sp>
+      <p:sp>
+        <p:nvSpPr>
+          <p:cNvPr id="7" name="Text 5"/>
+          <p:cNvSpPr/>
+          <p:nvPr/>
+        </p:nvSpPr>
+        <p:spPr>
+          <a:xfrm>
+            <a:off x="190500" y="142875"/>
+            <a:ext cx="7225665" cy="114300"/>
           </a:xfrm>
           <a:prstGeom prst="rect">
             <a:avLst/>
@@ -8125,7 +8592,7 @@
           <a:bodyPr wrap="square" lIns="0" tIns="0" rIns="0" bIns="0" rtlCol="0" anchor="ctr"/>
           <a:lstStyle/>
           <a:p>
-            <a:pPr marL="0" indent="0" algn="r">
+            <a:pPr marL="0" indent="0" algn="l">
               <a:lnSpc>
                 <a:spcPts val="865"/>
               </a:lnSpc>
@@ -8142,7 +8609,7 @@
                 <a:ea typeface="Cutive Mono" pitchFamily="34" charset="-122"/>
                 <a:cs typeface="Cutive Mono" pitchFamily="34" charset="-120"/>
               </a:rPr>
-              <a:t>2026-03-12</a:t>
+              <a:t>COMP3011 COURSEWORK 1 – INDIVIDUAL WEB SERVICES API DEVELOPMENT PROJECT</a:t>
             </a:r>
             <a:endParaRPr lang="en-US" sz="785" dirty="0"/>
           </a:p>
@@ -8150,845 +8617,115 @@
       </p:sp>
       <p:sp>
         <p:nvSpPr>
-          <p:cNvPr id="7" name="Text 5"/>
-          <p:cNvSpPr/>
-          <p:nvPr/>
-        </p:nvSpPr>
-        <p:spPr>
-          <a:xfrm>
-            <a:off x="190500" y="142875"/>
-            <a:ext cx="6637655" cy="114300"/>
-          </a:xfrm>
-          <a:prstGeom prst="rect">
-            <a:avLst/>
-          </a:prstGeom>
-          <a:noFill/>
-        </p:spPr>
-        <p:txBody>
-          <a:bodyPr wrap="square" lIns="0" tIns="0" rIns="0" bIns="0" rtlCol="0" anchor="ctr"/>
-          <a:lstStyle/>
-          <a:p>
-            <a:pPr marL="0" indent="0" algn="l">
-              <a:lnSpc>
-                <a:spcPts val="865"/>
-              </a:lnSpc>
-              <a:buNone/>
-            </a:pPr>
-            <a:r>
-              <a:rPr lang="en-US" sz="785" kern="0" spc="78" dirty="0">
-                <a:solidFill>
-                  <a:srgbClr val="000000">
-                    <a:alpha val="99000"/>
-                  </a:srgbClr>
-                </a:solidFill>
-                <a:latin typeface="Cutive Mono" pitchFamily="34" charset="0"/>
-                <a:ea typeface="Cutive Mono" pitchFamily="34" charset="-122"/>
-                <a:cs typeface="Cutive Mono" pitchFamily="34" charset="-120"/>
-              </a:rPr>
-              <a:t>COMP3011 COURSEWORK 1 – INDIVIDUAL WEB SERVICES API DEVELOPMENT PROJECT</a:t>
-            </a:r>
-            <a:endParaRPr lang="en-US" sz="785" dirty="0"/>
-          </a:p>
-        </p:txBody>
-      </p:sp>
-      <p:sp>
-        <p:nvSpPr>
-          <p:cNvPr id="8" name="Text 6"/>
-          <p:cNvSpPr/>
-          <p:nvPr>
-            <p:custDataLst>
-              <p:tags r:id="rId1"/>
-            </p:custDataLst>
-          </p:nvPr>
-        </p:nvSpPr>
-        <p:spPr>
-          <a:xfrm>
-            <a:off x="171450" y="1019175"/>
-            <a:ext cx="581025" cy="581025"/>
-          </a:xfrm>
-          <a:prstGeom prst="ellipse">
-            <a:avLst/>
-          </a:prstGeom>
-          <a:solidFill>
-            <a:srgbClr val="DCDBCE"/>
-          </a:solidFill>
-          <a:ln w="9049">
-            <a:solidFill>
-              <a:srgbClr val="000000"/>
-            </a:solidFill>
-          </a:ln>
-        </p:spPr>
-        <p:txBody>
-          <a:bodyPr wrap="square" rtlCol="0" anchor="ctr"/>
-          <a:lstStyle/>
-          <a:p>
-            <a:pPr marL="0" indent="0">
-              <a:buNone/>
-            </a:pPr>
-            <a:r>
-              <a:rPr lang="en-US" dirty="0">
-                <a:solidFill>
-                  <a:srgbClr val="000000"/>
-                </a:solidFill>
-              </a:rPr>
-              <a:t>A</a:t>
-            </a:r>
-            <a:endParaRPr lang="en-US" dirty="0"/>
-          </a:p>
-        </p:txBody>
-      </p:sp>
-      <p:sp>
-        <p:nvSpPr>
-          <p:cNvPr id="9" name="Text 7"/>
-          <p:cNvSpPr/>
-          <p:nvPr>
-            <p:custDataLst>
-              <p:tags r:id="rId2"/>
-            </p:custDataLst>
-          </p:nvPr>
-        </p:nvSpPr>
-        <p:spPr>
-          <a:xfrm>
-            <a:off x="3157538" y="1019175"/>
-            <a:ext cx="581025" cy="581025"/>
-          </a:xfrm>
-          <a:prstGeom prst="ellipse">
-            <a:avLst/>
-          </a:prstGeom>
-          <a:solidFill>
-            <a:srgbClr val="DCDBCE"/>
-          </a:solidFill>
-          <a:ln w="9049">
-            <a:solidFill>
-              <a:srgbClr val="000000"/>
-            </a:solidFill>
-          </a:ln>
-        </p:spPr>
-        <p:txBody>
-          <a:bodyPr wrap="square" rtlCol="0" anchor="ctr"/>
-          <a:lstStyle/>
-          <a:p>
-            <a:pPr marL="0" indent="0">
-              <a:buNone/>
-            </a:pPr>
-            <a:r>
-              <a:rPr lang="en-US" dirty="0">
-                <a:solidFill>
-                  <a:srgbClr val="000000"/>
-                </a:solidFill>
-              </a:rPr>
-              <a:t>B</a:t>
-            </a:r>
-            <a:endParaRPr lang="en-US" dirty="0"/>
-          </a:p>
-        </p:txBody>
-      </p:sp>
-      <p:sp>
-        <p:nvSpPr>
-          <p:cNvPr id="10" name="Text 8"/>
-          <p:cNvSpPr/>
-          <p:nvPr>
-            <p:custDataLst>
-              <p:tags r:id="rId3"/>
-            </p:custDataLst>
-          </p:nvPr>
-        </p:nvSpPr>
-        <p:spPr>
-          <a:xfrm>
-            <a:off x="6138863" y="1019175"/>
-            <a:ext cx="581025" cy="581025"/>
-          </a:xfrm>
-          <a:prstGeom prst="ellipse">
-            <a:avLst/>
-          </a:prstGeom>
-          <a:solidFill>
-            <a:srgbClr val="DCDBCE"/>
-          </a:solidFill>
-          <a:ln w="9049">
-            <a:solidFill>
-              <a:srgbClr val="000000"/>
-            </a:solidFill>
-          </a:ln>
-        </p:spPr>
-        <p:txBody>
-          <a:bodyPr wrap="square" rtlCol="0" anchor="ctr"/>
-          <a:lstStyle/>
-          <a:p>
-            <a:pPr marL="0" indent="0">
-              <a:buNone/>
-            </a:pPr>
-            <a:r>
-              <a:rPr lang="en-US" dirty="0">
-                <a:solidFill>
-                  <a:srgbClr val="000000"/>
-                </a:solidFill>
-              </a:rPr>
-              <a:t>C</a:t>
-            </a:r>
-            <a:endParaRPr lang="en-US" dirty="0"/>
-          </a:p>
-        </p:txBody>
-      </p:sp>
-      <p:sp>
-        <p:nvSpPr>
-          <p:cNvPr id="11" name="Text 9"/>
-          <p:cNvSpPr/>
-          <p:nvPr>
-            <p:custDataLst>
-              <p:tags r:id="rId4"/>
-            </p:custDataLst>
-          </p:nvPr>
-        </p:nvSpPr>
-        <p:spPr>
-          <a:xfrm>
-            <a:off x="866775" y="1171575"/>
-            <a:ext cx="2290763" cy="276225"/>
-          </a:xfrm>
-          <a:prstGeom prst="rect">
-            <a:avLst/>
-          </a:prstGeom>
-          <a:noFill/>
-        </p:spPr>
-        <p:txBody>
-          <a:bodyPr wrap="square" lIns="0" tIns="0" rIns="0" bIns="0" rtlCol="0" anchor="ctr"/>
-          <a:lstStyle/>
-          <a:p>
-            <a:pPr marL="0" indent="0" algn="l">
-              <a:lnSpc>
-                <a:spcPts val="2060"/>
-              </a:lnSpc>
-              <a:buNone/>
-            </a:pPr>
-            <a:r>
-              <a:rPr lang="en-US" sz="1425" kern="0" spc="-28" dirty="0">
-                <a:solidFill>
-                  <a:srgbClr val="000000">
-                    <a:alpha val="99000"/>
-                  </a:srgbClr>
-                </a:solidFill>
-                <a:latin typeface="微软雅黑" panose="020B0503020204020204" charset="-122"/>
-                <a:ea typeface="微软雅黑" panose="020B0503020204020204" charset="-122"/>
-                <a:cs typeface="Work Sans" pitchFamily="34" charset="-120"/>
-              </a:rPr>
-              <a:t>Testing</a:t>
-            </a:r>
-            <a:endParaRPr lang="en-US" sz="1425" dirty="0">
-              <a:latin typeface="微软雅黑" panose="020B0503020204020204" charset="-122"/>
-              <a:ea typeface="微软雅黑" panose="020B0503020204020204" charset="-122"/>
+          <p:cNvPr id="8" name="文本框 7"/>
+          <p:cNvSpPr txBox="1"/>
+          <p:nvPr/>
+        </p:nvSpPr>
+        <p:spPr>
+          <a:xfrm>
+            <a:off x="5905500" y="1417955"/>
+            <a:ext cx="3048000" cy="2306955"/>
+          </a:xfrm>
+          <a:prstGeom prst="rect">
+            <a:avLst/>
+          </a:prstGeom>
+          <a:noFill/>
+        </p:spPr>
+        <p:txBody>
+          <a:bodyPr wrap="square" rtlCol="0">
+            <a:spAutoFit/>
+          </a:bodyPr>
+          <a:p>
+            <a:pPr marL="285750" indent="-285750">
+              <a:buFont typeface="Arial" panose="020B0604020202090204" pitchFamily="34" charset="0"/>
+              <a:buChar char="•"/>
+            </a:pPr>
+            <a:r>
+              <a:rPr lang="en-US" altLang="zh-CN" sz="1600">
+                <a:latin typeface="微软雅黑" charset="0"/>
+                <a:ea typeface="微软雅黑" charset="0"/>
+              </a:rPr>
+              <a:t>Loads historical rent data by area and time period</a:t>
+            </a:r>
+            <a:endParaRPr lang="en-US" altLang="zh-CN" sz="1600">
+              <a:latin typeface="微软雅黑" charset="0"/>
+              <a:ea typeface="微软雅黑" charset="0"/>
             </a:endParaRPr>
           </a:p>
-        </p:txBody>
-      </p:sp>
-      <p:sp>
-        <p:nvSpPr>
-          <p:cNvPr id="12" name="Text 10"/>
-          <p:cNvSpPr/>
-          <p:nvPr>
-            <p:custDataLst>
-              <p:tags r:id="rId5"/>
-            </p:custDataLst>
-          </p:nvPr>
-        </p:nvSpPr>
-        <p:spPr>
-          <a:xfrm>
-            <a:off x="3848100" y="1171575"/>
-            <a:ext cx="2290763" cy="276225"/>
-          </a:xfrm>
-          <a:prstGeom prst="rect">
-            <a:avLst/>
-          </a:prstGeom>
-          <a:noFill/>
-        </p:spPr>
-        <p:txBody>
-          <a:bodyPr wrap="square" lIns="0" tIns="0" rIns="0" bIns="0" rtlCol="0" anchor="ctr"/>
-          <a:lstStyle/>
-          <a:p>
-            <a:pPr marL="0" indent="0" algn="l">
-              <a:lnSpc>
-                <a:spcPts val="2060"/>
-              </a:lnSpc>
-              <a:buNone/>
-            </a:pPr>
-            <a:r>
-              <a:rPr lang="en-US" sz="1425" kern="0" spc="-28" dirty="0">
-                <a:solidFill>
-                  <a:srgbClr val="000000">
-                    <a:alpha val="99000"/>
-                  </a:srgbClr>
-                </a:solidFill>
-                <a:latin typeface="微软雅黑" panose="020B0503020204020204" charset="-122"/>
-                <a:ea typeface="微软雅黑" panose="020B0503020204020204" charset="-122"/>
-                <a:cs typeface="Work Sans" pitchFamily="34" charset="-120"/>
-              </a:rPr>
-              <a:t>Deployment</a:t>
-            </a:r>
-            <a:endParaRPr lang="en-US" sz="1425" dirty="0">
-              <a:latin typeface="微软雅黑" panose="020B0503020204020204" charset="-122"/>
-              <a:ea typeface="微软雅黑" panose="020B0503020204020204" charset="-122"/>
+          <a:p>
+            <a:pPr marL="285750" indent="-285750">
+              <a:buFont typeface="Arial" panose="020B0604020202090204" pitchFamily="34" charset="0"/>
+              <a:buChar char="•"/>
+            </a:pPr>
+            <a:endParaRPr lang="en-US" altLang="zh-CN" sz="1600">
+              <a:latin typeface="微软雅黑" charset="0"/>
+              <a:ea typeface="微软雅黑" charset="0"/>
             </a:endParaRPr>
           </a:p>
-        </p:txBody>
-      </p:sp>
-      <p:sp>
-        <p:nvSpPr>
-          <p:cNvPr id="13" name="Text 11"/>
-          <p:cNvSpPr/>
-          <p:nvPr>
-            <p:custDataLst>
-              <p:tags r:id="rId6"/>
-            </p:custDataLst>
-          </p:nvPr>
-        </p:nvSpPr>
-        <p:spPr>
-          <a:xfrm>
-            <a:off x="6829425" y="1171575"/>
-            <a:ext cx="2290763" cy="276225"/>
-          </a:xfrm>
-          <a:prstGeom prst="rect">
-            <a:avLst/>
-          </a:prstGeom>
-          <a:noFill/>
-        </p:spPr>
-        <p:txBody>
-          <a:bodyPr wrap="square" lIns="0" tIns="0" rIns="0" bIns="0" rtlCol="0" anchor="ctr"/>
-          <a:lstStyle/>
-          <a:p>
-            <a:pPr marL="0" indent="0" algn="l">
-              <a:lnSpc>
-                <a:spcPts val="2060"/>
-              </a:lnSpc>
-              <a:buNone/>
-            </a:pPr>
-            <a:r>
-              <a:rPr lang="en-US" sz="1425" kern="0" spc="-28" dirty="0">
-                <a:solidFill>
-                  <a:srgbClr val="000000">
-                    <a:alpha val="99000"/>
-                  </a:srgbClr>
-                </a:solidFill>
-                <a:latin typeface="微软雅黑" panose="020B0503020204020204" charset="-122"/>
-                <a:ea typeface="微软雅黑" panose="020B0503020204020204" charset="-122"/>
-                <a:cs typeface="Work Sans" pitchFamily="34" charset="-120"/>
-              </a:rPr>
-              <a:t>Deliverables</a:t>
-            </a:r>
-            <a:endParaRPr lang="en-US" sz="1425" dirty="0">
-              <a:latin typeface="微软雅黑" panose="020B0503020204020204" charset="-122"/>
-              <a:ea typeface="微软雅黑" panose="020B0503020204020204" charset="-122"/>
+          <a:p>
+            <a:pPr marL="285750" indent="-285750">
+              <a:buFont typeface="Arial" panose="020B0604020202090204" pitchFamily="34" charset="0"/>
+              <a:buChar char="•"/>
+            </a:pPr>
+            <a:r>
+              <a:rPr lang="en-US" altLang="zh-CN" sz="1600">
+                <a:latin typeface="微软雅黑" charset="0"/>
+                <a:ea typeface="微软雅黑" charset="0"/>
+              </a:rPr>
+              <a:t>Supports area selection and side-by-side  comparison</a:t>
+            </a:r>
+            <a:endParaRPr lang="en-US" altLang="zh-CN" sz="1600">
+              <a:latin typeface="微软雅黑" charset="0"/>
+              <a:ea typeface="微软雅黑" charset="0"/>
             </a:endParaRPr>
           </a:p>
-        </p:txBody>
-      </p:sp>
-      <p:sp>
-        <p:nvSpPr>
-          <p:cNvPr id="14" name="Text 12"/>
-          <p:cNvSpPr/>
-          <p:nvPr>
-            <p:custDataLst>
-              <p:tags r:id="rId7"/>
-            </p:custDataLst>
-          </p:nvPr>
-        </p:nvSpPr>
-        <p:spPr>
-          <a:xfrm>
-            <a:off x="85725" y="1828483"/>
-            <a:ext cx="2667000" cy="1104900"/>
-          </a:xfrm>
-          <a:prstGeom prst="rect">
-            <a:avLst/>
-          </a:prstGeom>
-          <a:noFill/>
-        </p:spPr>
-        <p:txBody>
-          <a:bodyPr wrap="square" lIns="0" tIns="0" rIns="0" bIns="0" rtlCol="0" anchor="ctr"/>
-          <a:lstStyle/>
-          <a:p>
-            <a:pPr marL="342900" indent="-342900" algn="l">
-              <a:lnSpc>
-                <a:spcPts val="2060"/>
-              </a:lnSpc>
-              <a:buSzPct val="100000"/>
+          <a:p>
+            <a:pPr marL="285750" indent="-285750">
+              <a:buFont typeface="Arial" panose="020B0604020202090204" pitchFamily="34" charset="0"/>
               <a:buChar char="•"/>
             </a:pPr>
-            <a:r>
-              <a:rPr lang="en-US" sz="855" kern="0" spc="-17" dirty="0">
-                <a:solidFill>
-                  <a:srgbClr val="000000">
-                    <a:alpha val="99000"/>
-                  </a:srgbClr>
-                </a:solidFill>
-                <a:latin typeface="微软雅黑" panose="020B0503020204020204" charset="-122"/>
-                <a:ea typeface="微软雅黑" panose="020B0503020204020204" charset="-122"/>
-                <a:cs typeface="Work Sans" pitchFamily="34" charset="-120"/>
-              </a:rPr>
-              <a:t>Endpoint tests with pytest</a:t>
-            </a:r>
-            <a:endParaRPr lang="en-US" sz="855" dirty="0">
-              <a:latin typeface="微软雅黑" panose="020B0503020204020204" charset="-122"/>
-              <a:ea typeface="微软雅黑" panose="020B0503020204020204" charset="-122"/>
+            <a:endParaRPr lang="en-US" altLang="zh-CN" sz="1600">
+              <a:latin typeface="微软雅黑" charset="0"/>
+              <a:ea typeface="微软雅黑" charset="0"/>
             </a:endParaRPr>
           </a:p>
           <a:p>
-            <a:pPr marL="342900" indent="-342900" algn="l">
-              <a:lnSpc>
-                <a:spcPts val="2060"/>
-              </a:lnSpc>
-              <a:buSzPct val="100000"/>
+            <a:pPr marL="285750" indent="-285750">
+              <a:buFont typeface="Arial" panose="020B0604020202090204" pitchFamily="34" charset="0"/>
               <a:buChar char="•"/>
             </a:pPr>
             <a:r>
-              <a:rPr lang="en-US" sz="855" kern="0" spc="-17" dirty="0">
-                <a:solidFill>
-                  <a:srgbClr val="000000">
-                    <a:alpha val="99000"/>
-                  </a:srgbClr>
-                </a:solidFill>
-                <a:latin typeface="微软雅黑" panose="020B0503020204020204" charset="-122"/>
-                <a:ea typeface="微软雅黑" panose="020B0503020204020204" charset="-122"/>
-                <a:cs typeface="Work Sans" pitchFamily="34" charset="-120"/>
-              </a:rPr>
-              <a:t>Validation of success and error cases</a:t>
-            </a:r>
-            <a:endParaRPr lang="en-US" sz="855" dirty="0">
-              <a:latin typeface="微软雅黑" panose="020B0503020204020204" charset="-122"/>
-              <a:ea typeface="微软雅黑" panose="020B0503020204020204" charset="-122"/>
-            </a:endParaRPr>
-          </a:p>
-          <a:p>
-            <a:pPr marL="342900" indent="-342900" algn="l">
-              <a:lnSpc>
-                <a:spcPts val="2060"/>
-              </a:lnSpc>
-              <a:buSzPct val="100000"/>
-              <a:buChar char="•"/>
-            </a:pPr>
-            <a:r>
-              <a:rPr lang="en-US" sz="855" kern="0" spc="-17" dirty="0">
-                <a:solidFill>
-                  <a:srgbClr val="000000">
-                    <a:alpha val="99000"/>
-                  </a:srgbClr>
-                </a:solidFill>
-                <a:latin typeface="微软雅黑" panose="020B0503020204020204" charset="-122"/>
-                <a:ea typeface="微软雅黑" panose="020B0503020204020204" charset="-122"/>
-                <a:cs typeface="Work Sans" pitchFamily="34" charset="-120"/>
-              </a:rPr>
-              <a:t>Coverage of query parameters and edge cases</a:t>
-            </a:r>
-            <a:endParaRPr lang="en-US" sz="855" dirty="0">
-              <a:latin typeface="微软雅黑" panose="020B0503020204020204" charset="-122"/>
-              <a:ea typeface="微软雅黑" panose="020B0503020204020204" charset="-122"/>
-            </a:endParaRPr>
-          </a:p>
-          <a:p>
-            <a:pPr marL="342900" indent="-342900" algn="l">
-              <a:lnSpc>
-                <a:spcPts val="2060"/>
-              </a:lnSpc>
-              <a:buSzPct val="100000"/>
-              <a:buChar char="•"/>
-            </a:pPr>
-            <a:r>
-              <a:rPr lang="en-US" sz="855" kern="0" spc="-17" dirty="0">
-                <a:solidFill>
-                  <a:srgbClr val="000000">
-                    <a:alpha val="99000"/>
-                  </a:srgbClr>
-                </a:solidFill>
-                <a:latin typeface="微软雅黑" panose="020B0503020204020204" charset="-122"/>
-                <a:ea typeface="微软雅黑" panose="020B0503020204020204" charset="-122"/>
-                <a:cs typeface="Work Sans" pitchFamily="34" charset="-120"/>
-              </a:rPr>
-              <a:t>Verified expected status codes and responses</a:t>
-            </a:r>
-            <a:endParaRPr lang="en-US" sz="855" dirty="0">
-              <a:latin typeface="微软雅黑" panose="020B0503020204020204" charset="-122"/>
-              <a:ea typeface="微软雅黑" panose="020B0503020204020204" charset="-122"/>
-            </a:endParaRPr>
-          </a:p>
-        </p:txBody>
-      </p:sp>
-      <p:sp>
-        <p:nvSpPr>
-          <p:cNvPr id="15" name="Text 13"/>
-          <p:cNvSpPr/>
-          <p:nvPr>
-            <p:custDataLst>
-              <p:tags r:id="rId8"/>
-            </p:custDataLst>
-          </p:nvPr>
-        </p:nvSpPr>
-        <p:spPr>
-          <a:xfrm>
-            <a:off x="6138863" y="1614488"/>
-            <a:ext cx="2667000" cy="1376363"/>
-          </a:xfrm>
-          <a:prstGeom prst="rect">
-            <a:avLst/>
-          </a:prstGeom>
-          <a:noFill/>
-        </p:spPr>
-        <p:txBody>
-          <a:bodyPr wrap="square" lIns="0" tIns="0" rIns="0" bIns="0" rtlCol="0" anchor="ctr"/>
-          <a:lstStyle/>
-          <a:p>
-            <a:pPr marL="342900" indent="-342900" algn="l">
-              <a:lnSpc>
-                <a:spcPts val="2060"/>
-              </a:lnSpc>
-              <a:buSzPct val="100000"/>
-              <a:buChar char="•"/>
-            </a:pPr>
-            <a:r>
-              <a:rPr lang="en-US" sz="855" kern="0" spc="-17" dirty="0">
-                <a:solidFill>
-                  <a:srgbClr val="000000">
-                    <a:alpha val="99000"/>
-                  </a:srgbClr>
-                </a:solidFill>
-                <a:latin typeface="微软雅黑" panose="020B0503020204020204" charset="-122"/>
-                <a:ea typeface="微软雅黑" panose="020B0503020204020204" charset="-122"/>
-                <a:cs typeface="Work Sans" pitchFamily="34" charset="-120"/>
-              </a:rPr>
-              <a:t>Public GitHub repository with commit history</a:t>
-            </a:r>
-            <a:endParaRPr lang="en-US" sz="855" dirty="0">
-              <a:latin typeface="微软雅黑" panose="020B0503020204020204" charset="-122"/>
-              <a:ea typeface="微软雅黑" panose="020B0503020204020204" charset="-122"/>
-            </a:endParaRPr>
-          </a:p>
-          <a:p>
-            <a:pPr marL="342900" indent="-342900" algn="l">
-              <a:lnSpc>
-                <a:spcPts val="2060"/>
-              </a:lnSpc>
-              <a:buSzPct val="100000"/>
-              <a:buChar char="•"/>
-            </a:pPr>
-            <a:r>
-              <a:rPr lang="en-US" sz="855" kern="0" spc="-17" dirty="0">
-                <a:solidFill>
-                  <a:srgbClr val="000000">
-                    <a:alpha val="99000"/>
-                  </a:srgbClr>
-                </a:solidFill>
-                <a:latin typeface="微软雅黑" panose="020B0503020204020204" charset="-122"/>
-                <a:ea typeface="微软雅黑" panose="020B0503020204020204" charset="-122"/>
-                <a:cs typeface="Work Sans" pitchFamily="34" charset="-120"/>
-              </a:rPr>
-              <a:t>API documentation and technical report</a:t>
-            </a:r>
-            <a:endParaRPr lang="en-US" sz="855" dirty="0">
-              <a:latin typeface="微软雅黑" panose="020B0503020204020204" charset="-122"/>
-              <a:ea typeface="微软雅黑" panose="020B0503020204020204" charset="-122"/>
-            </a:endParaRPr>
-          </a:p>
-          <a:p>
-            <a:pPr marL="342900" indent="-342900" algn="l">
-              <a:lnSpc>
-                <a:spcPts val="2060"/>
-              </a:lnSpc>
-              <a:buSzPct val="100000"/>
-              <a:buChar char="•"/>
-            </a:pPr>
-            <a:r>
-              <a:rPr lang="en-US" sz="855" kern="0" spc="-17" dirty="0">
-                <a:solidFill>
-                  <a:srgbClr val="000000">
-                    <a:alpha val="99000"/>
-                  </a:srgbClr>
-                </a:solidFill>
-                <a:latin typeface="微软雅黑" panose="020B0503020204020204" charset="-122"/>
-                <a:ea typeface="微软雅黑" panose="020B0503020204020204" charset="-122"/>
-                <a:cs typeface="Work Sans" pitchFamily="34" charset="-120"/>
-              </a:rPr>
-              <a:t>Source code, database setup, and evidence of development</a:t>
-            </a:r>
-            <a:endParaRPr lang="en-US" sz="855" dirty="0">
-              <a:latin typeface="微软雅黑" panose="020B0503020204020204" charset="-122"/>
-              <a:ea typeface="微软雅黑" panose="020B0503020204020204" charset="-122"/>
-            </a:endParaRPr>
-          </a:p>
-          <a:p>
-            <a:pPr marL="342900" indent="-342900" algn="l">
-              <a:lnSpc>
-                <a:spcPts val="2060"/>
-              </a:lnSpc>
-              <a:buSzPct val="100000"/>
-              <a:buChar char="•"/>
-            </a:pPr>
-            <a:r>
-              <a:rPr lang="en-US" sz="855" kern="0" spc="-17" dirty="0">
-                <a:solidFill>
-                  <a:srgbClr val="000000">
-                    <a:alpha val="99000"/>
-                  </a:srgbClr>
-                </a:solidFill>
-                <a:latin typeface="微软雅黑" panose="020B0503020204020204" charset="-122"/>
-                <a:ea typeface="微软雅黑" panose="020B0503020204020204" charset="-122"/>
-                <a:cs typeface="Work Sans" pitchFamily="34" charset="-120"/>
-              </a:rPr>
-              <a:t>Presentation and submission-ready materials</a:t>
-            </a:r>
-            <a:endParaRPr lang="en-US" sz="855" dirty="0">
-              <a:latin typeface="微软雅黑" panose="020B0503020204020204" charset="-122"/>
-              <a:ea typeface="微软雅黑" panose="020B0503020204020204" charset="-122"/>
-            </a:endParaRPr>
-          </a:p>
-        </p:txBody>
-      </p:sp>
-      <p:sp>
-        <p:nvSpPr>
-          <p:cNvPr id="16" name="Text 14"/>
-          <p:cNvSpPr/>
-          <p:nvPr>
-            <p:custDataLst>
-              <p:tags r:id="rId9"/>
-            </p:custDataLst>
-          </p:nvPr>
-        </p:nvSpPr>
-        <p:spPr>
-          <a:xfrm>
-            <a:off x="3157538" y="1614488"/>
-            <a:ext cx="2662238" cy="1104900"/>
-          </a:xfrm>
-          <a:prstGeom prst="rect">
-            <a:avLst/>
-          </a:prstGeom>
-          <a:noFill/>
-        </p:spPr>
-        <p:txBody>
-          <a:bodyPr wrap="square" lIns="0" tIns="0" rIns="0" bIns="0" rtlCol="0" anchor="ctr"/>
-          <a:lstStyle/>
-          <a:p>
-            <a:pPr marL="342900" indent="-342900" algn="l">
-              <a:lnSpc>
-                <a:spcPts val="2060"/>
-              </a:lnSpc>
-              <a:buSzPct val="100000"/>
-              <a:buChar char="•"/>
-            </a:pPr>
-            <a:r>
-              <a:rPr lang="en-US" sz="855" kern="0" spc="-17" dirty="0">
-                <a:solidFill>
-                  <a:srgbClr val="000000">
-                    <a:alpha val="99000"/>
-                  </a:srgbClr>
-                </a:solidFill>
-                <a:latin typeface="微软雅黑" panose="020B0503020204020204" charset="-122"/>
-                <a:ea typeface="微软雅黑" panose="020B0503020204020204" charset="-122"/>
-                <a:cs typeface="Work Sans" pitchFamily="34" charset="-120"/>
-              </a:rPr>
-              <a:t>Deployed as a runnable web service</a:t>
-            </a:r>
-            <a:endParaRPr lang="en-US" sz="855" dirty="0">
-              <a:latin typeface="微软雅黑" panose="020B0503020204020204" charset="-122"/>
-              <a:ea typeface="微软雅黑" panose="020B0503020204020204" charset="-122"/>
-            </a:endParaRPr>
-          </a:p>
-          <a:p>
-            <a:pPr marL="342900" indent="-342900" algn="l">
-              <a:lnSpc>
-                <a:spcPts val="2060"/>
-              </a:lnSpc>
-              <a:buSzPct val="100000"/>
-              <a:buChar char="•"/>
-            </a:pPr>
-            <a:r>
-              <a:rPr lang="en-US" sz="855" kern="0" spc="-17" dirty="0">
-                <a:solidFill>
-                  <a:srgbClr val="000000">
-                    <a:alpha val="99000"/>
-                  </a:srgbClr>
-                </a:solidFill>
-                <a:latin typeface="微软雅黑" panose="020B0503020204020204" charset="-122"/>
-                <a:ea typeface="微软雅黑" panose="020B0503020204020204" charset="-122"/>
-                <a:cs typeface="Work Sans" pitchFamily="34" charset="-120"/>
-              </a:rPr>
-              <a:t>Interactive API documentation available</a:t>
-            </a:r>
-            <a:endParaRPr lang="en-US" sz="855" dirty="0">
-              <a:latin typeface="微软雅黑" panose="020B0503020204020204" charset="-122"/>
-              <a:ea typeface="微软雅黑" panose="020B0503020204020204" charset="-122"/>
-            </a:endParaRPr>
-          </a:p>
-          <a:p>
-            <a:pPr marL="342900" indent="-342900" algn="l">
-              <a:lnSpc>
-                <a:spcPts val="2060"/>
-              </a:lnSpc>
-              <a:buSzPct val="100000"/>
-              <a:buChar char="•"/>
-            </a:pPr>
-            <a:r>
-              <a:rPr lang="en-US" sz="855" kern="0" spc="-17" dirty="0">
-                <a:solidFill>
-                  <a:srgbClr val="000000">
-                    <a:alpha val="99000"/>
-                  </a:srgbClr>
-                </a:solidFill>
-                <a:latin typeface="微软雅黑" panose="020B0503020204020204" charset="-122"/>
-                <a:ea typeface="微软雅黑" panose="020B0503020204020204" charset="-122"/>
-                <a:cs typeface="Work Sans" pitchFamily="34" charset="-120"/>
-              </a:rPr>
-              <a:t>Submission version aligned with hosted demo</a:t>
-            </a:r>
-            <a:endParaRPr lang="en-US" sz="855" dirty="0">
-              <a:latin typeface="微软雅黑" panose="020B0503020204020204" charset="-122"/>
-              <a:ea typeface="微软雅黑" panose="020B0503020204020204" charset="-122"/>
-            </a:endParaRPr>
-          </a:p>
-          <a:p>
-            <a:pPr marL="342900" indent="-342900" algn="l">
-              <a:lnSpc>
-                <a:spcPts val="2060"/>
-              </a:lnSpc>
-              <a:buSzPct val="100000"/>
-              <a:buChar char="•"/>
-            </a:pPr>
-            <a:r>
-              <a:rPr lang="en-US" sz="855" kern="0" spc="-17" dirty="0">
-                <a:solidFill>
-                  <a:srgbClr val="000000">
-                    <a:alpha val="99000"/>
-                  </a:srgbClr>
-                </a:solidFill>
-                <a:latin typeface="微软雅黑" panose="020B0503020204020204" charset="-122"/>
-                <a:ea typeface="微软雅黑" panose="020B0503020204020204" charset="-122"/>
-                <a:cs typeface="Work Sans" pitchFamily="34" charset="-120"/>
-              </a:rPr>
-              <a:t>CI/CD used for deployment validation</a:t>
-            </a:r>
-            <a:endParaRPr lang="en-US" sz="855" dirty="0">
-              <a:latin typeface="微软雅黑" panose="020B0503020204020204" charset="-122"/>
-              <a:ea typeface="微软雅黑" panose="020B0503020204020204" charset="-122"/>
+              <a:rPr lang="en-US" altLang="zh-CN" sz="1600">
+                <a:latin typeface="微软雅黑" charset="0"/>
+                <a:ea typeface="微软雅黑" charset="0"/>
+              </a:rPr>
+              <a:t>Improves interpretability for non-technical users</a:t>
+            </a:r>
+            <a:endParaRPr lang="en-US" altLang="zh-CN" sz="1600">
+              <a:latin typeface="微软雅黑" charset="0"/>
+              <a:ea typeface="微软雅黑" charset="0"/>
             </a:endParaRPr>
           </a:p>
         </p:txBody>
       </p:sp>
       <p:pic>
         <p:nvPicPr>
-          <p:cNvPr id="17" name="Image 0" descr="preencoded.png"/>
+          <p:cNvPr id="9" name="图片 8"/>
           <p:cNvPicPr>
             <a:picLocks noChangeAspect="1"/>
           </p:cNvPicPr>
           <p:nvPr/>
         </p:nvPicPr>
         <p:blipFill>
-          <a:blip r:embed="rId10"/>
-          <a:srcRect/>
+          <a:blip r:embed="rId1"/>
           <a:stretch>
             <a:fillRect/>
           </a:stretch>
         </p:blipFill>
         <p:spPr>
           <a:xfrm>
-            <a:off x="190500" y="3333750"/>
-            <a:ext cx="2085975" cy="1185863"/>
-          </a:xfrm>
-          <a:prstGeom prst="rect">
-            <a:avLst/>
-          </a:prstGeom>
-        </p:spPr>
-      </p:pic>
-      <p:pic>
-        <p:nvPicPr>
-          <p:cNvPr id="18" name="Image 1" descr="preencoded.png"/>
-          <p:cNvPicPr>
-            <a:picLocks noChangeAspect="1"/>
-          </p:cNvPicPr>
-          <p:nvPr>
-            <p:custDataLst>
-              <p:tags r:id="rId11"/>
-            </p:custDataLst>
-          </p:nvPr>
-        </p:nvPicPr>
-        <p:blipFill>
-          <a:blip r:embed="rId12"/>
-          <a:srcRect/>
-          <a:stretch>
-            <a:fillRect/>
-          </a:stretch>
-        </p:blipFill>
-        <p:spPr>
-          <a:xfrm>
-            <a:off x="3305175" y="2866708"/>
-            <a:ext cx="2366963" cy="514350"/>
-          </a:xfrm>
-          <a:prstGeom prst="rect">
-            <a:avLst/>
-          </a:prstGeom>
-        </p:spPr>
-      </p:pic>
-      <p:pic>
-        <p:nvPicPr>
-          <p:cNvPr id="19" name="Image 2" descr="preencoded.png"/>
-          <p:cNvPicPr>
-            <a:picLocks noChangeAspect="1"/>
-          </p:cNvPicPr>
-          <p:nvPr/>
-        </p:nvPicPr>
-        <p:blipFill>
-          <a:blip r:embed="rId13"/>
-          <a:srcRect/>
-          <a:stretch>
-            <a:fillRect/>
-          </a:stretch>
-        </p:blipFill>
-        <p:spPr>
-          <a:xfrm>
-            <a:off x="3243263" y="3529013"/>
-            <a:ext cx="2547938" cy="885825"/>
-          </a:xfrm>
-          <a:prstGeom prst="rect">
-            <a:avLst/>
-          </a:prstGeom>
-        </p:spPr>
-      </p:pic>
-      <p:pic>
-        <p:nvPicPr>
-          <p:cNvPr id="20" name="Image 3" descr="preencoded.png"/>
-          <p:cNvPicPr>
-            <a:picLocks noChangeAspect="1"/>
-          </p:cNvPicPr>
-          <p:nvPr/>
-        </p:nvPicPr>
-        <p:blipFill>
-          <a:blip r:embed="rId14"/>
-          <a:srcRect/>
-          <a:stretch>
-            <a:fillRect/>
-          </a:stretch>
-        </p:blipFill>
-        <p:spPr>
-          <a:xfrm>
-            <a:off x="6138863" y="2990850"/>
-            <a:ext cx="1162050" cy="1133475"/>
-          </a:xfrm>
-          <a:prstGeom prst="rect">
-            <a:avLst/>
-          </a:prstGeom>
-        </p:spPr>
-      </p:pic>
-      <p:pic>
-        <p:nvPicPr>
-          <p:cNvPr id="21" name="Image 4" descr="preencoded.png"/>
-          <p:cNvPicPr>
-            <a:picLocks noChangeAspect="1"/>
-          </p:cNvPicPr>
-          <p:nvPr/>
-        </p:nvPicPr>
-        <p:blipFill>
-          <a:blip r:embed="rId15"/>
-          <a:srcRect/>
-          <a:stretch>
-            <a:fillRect/>
-          </a:stretch>
-        </p:blipFill>
-        <p:spPr>
-          <a:xfrm>
-            <a:off x="7472363" y="2990850"/>
-            <a:ext cx="1085850" cy="1528763"/>
+            <a:off x="94615" y="1024255"/>
+            <a:ext cx="5706745" cy="3038475"/>
           </a:xfrm>
           <a:prstGeom prst="rect">
             <a:avLst/>
@@ -9082,8 +8819,8 @@
         </p:nvSpPr>
         <p:spPr>
           <a:xfrm>
-            <a:off x="186055" y="485775"/>
-            <a:ext cx="7280910" cy="304800"/>
+            <a:off x="185738" y="485775"/>
+            <a:ext cx="4738688" cy="304800"/>
           </a:xfrm>
           <a:prstGeom prst="rect">
             <a:avLst/>
@@ -9101,13 +8838,19 @@
               <a:buNone/>
             </a:pPr>
             <a:r>
-              <a:rPr lang="en-US" altLang="zh-CN" sz="1780" b="1" dirty="0">
+              <a:rPr lang="en-US" sz="1780" b="1" kern="0" spc="-36" dirty="0">
+                <a:solidFill>
+                  <a:srgbClr val="000000">
+                    <a:alpha val="99000"/>
+                  </a:srgbClr>
+                </a:solidFill>
                 <a:latin typeface="微软雅黑" panose="020B0503020204020204" charset="-122"/>
                 <a:ea typeface="微软雅黑" panose="020B0503020204020204" charset="-122"/>
-              </a:rPr>
-              <a:t>Version Control Practices and Commit History</a:t>
-            </a:r>
-            <a:endParaRPr lang="en-US" altLang="zh-CN" sz="1780" b="1" dirty="0">
+                <a:cs typeface="Work Sans" pitchFamily="34" charset="-120"/>
+              </a:rPr>
+              <a:t>Testing, Deployment, and Deliverables</a:t>
+            </a:r>
+            <a:endParaRPr lang="en-US" sz="1780" dirty="0">
               <a:latin typeface="微软雅黑" panose="020B0503020204020204" charset="-122"/>
               <a:ea typeface="微软雅黑" panose="020B0503020204020204" charset="-122"/>
             </a:endParaRPr>
@@ -9245,77 +8988,698 @@
       </p:sp>
       <p:sp>
         <p:nvSpPr>
-          <p:cNvPr id="22" name="文本框 21"/>
-          <p:cNvSpPr txBox="1"/>
-          <p:nvPr/>
-        </p:nvSpPr>
-        <p:spPr>
-          <a:xfrm>
-            <a:off x="190500" y="790575"/>
-            <a:ext cx="8290560" cy="1076325"/>
-          </a:xfrm>
-          <a:prstGeom prst="rect">
-            <a:avLst/>
-          </a:prstGeom>
-          <a:noFill/>
-        </p:spPr>
-        <p:txBody>
-          <a:bodyPr wrap="square" rtlCol="0">
-            <a:spAutoFit/>
-          </a:bodyPr>
-          <a:p>
-            <a:pPr marL="285750" indent="-285750">
-              <a:buFont typeface="Wingdings" panose="05000000000000000000" charset="0"/>
-              <a:buChar char="l"/>
-            </a:pPr>
-            <a:r>
-              <a:rPr lang="en-US" altLang="zh-CN" sz="1600"/>
-              <a:t>Public GitHub repository used throughout development.</a:t>
-            </a:r>
-            <a:endParaRPr lang="en-US" altLang="zh-CN" sz="1600"/>
-          </a:p>
-          <a:p>
-            <a:pPr marL="285750" indent="-285750">
-              <a:buFont typeface="Wingdings" panose="05000000000000000000" charset="0"/>
-              <a:buChar char="l"/>
-            </a:pPr>
-            <a:r>
-              <a:rPr lang="en-US" altLang="zh-CN" sz="1600"/>
-              <a:t>Incremental commits documented database setup, API implementation, testing, and deployment changes.</a:t>
-            </a:r>
-            <a:endParaRPr lang="en-US" altLang="zh-CN" sz="1600"/>
-          </a:p>
-          <a:p>
-            <a:pPr marL="285750" indent="-285750">
-              <a:buFont typeface="Wingdings" panose="05000000000000000000" charset="0"/>
-              <a:buChar char="l"/>
-            </a:pPr>
-            <a:r>
-              <a:rPr lang="en-US" altLang="zh-CN" sz="1600"/>
-              <a:t>Commit history reflects staged development rather than one-time upload.</a:t>
-            </a:r>
-            <a:endParaRPr lang="en-US" altLang="zh-CN" sz="1600"/>
+          <p:cNvPr id="8" name="Text 6"/>
+          <p:cNvSpPr/>
+          <p:nvPr>
+            <p:custDataLst>
+              <p:tags r:id="rId1"/>
+            </p:custDataLst>
+          </p:nvPr>
+        </p:nvSpPr>
+        <p:spPr>
+          <a:xfrm>
+            <a:off x="171450" y="1019175"/>
+            <a:ext cx="581025" cy="581025"/>
+          </a:xfrm>
+          <a:prstGeom prst="ellipse">
+            <a:avLst/>
+          </a:prstGeom>
+          <a:solidFill>
+            <a:srgbClr val="DCDBCE"/>
+          </a:solidFill>
+          <a:ln w="9049">
+            <a:solidFill>
+              <a:srgbClr val="000000"/>
+            </a:solidFill>
+          </a:ln>
+        </p:spPr>
+        <p:txBody>
+          <a:bodyPr wrap="square" rtlCol="0" anchor="ctr"/>
+          <a:lstStyle/>
+          <a:p>
+            <a:pPr marL="0" indent="0">
+              <a:buNone/>
+            </a:pPr>
+            <a:r>
+              <a:rPr lang="en-US" dirty="0">
+                <a:solidFill>
+                  <a:srgbClr val="000000"/>
+                </a:solidFill>
+              </a:rPr>
+              <a:t>A</a:t>
+            </a:r>
+            <a:endParaRPr lang="en-US" dirty="0"/>
+          </a:p>
+        </p:txBody>
+      </p:sp>
+      <p:sp>
+        <p:nvSpPr>
+          <p:cNvPr id="9" name="Text 7"/>
+          <p:cNvSpPr/>
+          <p:nvPr>
+            <p:custDataLst>
+              <p:tags r:id="rId2"/>
+            </p:custDataLst>
+          </p:nvPr>
+        </p:nvSpPr>
+        <p:spPr>
+          <a:xfrm>
+            <a:off x="3157538" y="1019175"/>
+            <a:ext cx="581025" cy="581025"/>
+          </a:xfrm>
+          <a:prstGeom prst="ellipse">
+            <a:avLst/>
+          </a:prstGeom>
+          <a:solidFill>
+            <a:srgbClr val="DCDBCE"/>
+          </a:solidFill>
+          <a:ln w="9049">
+            <a:solidFill>
+              <a:srgbClr val="000000"/>
+            </a:solidFill>
+          </a:ln>
+        </p:spPr>
+        <p:txBody>
+          <a:bodyPr wrap="square" rtlCol="0" anchor="ctr"/>
+          <a:lstStyle/>
+          <a:p>
+            <a:pPr marL="0" indent="0">
+              <a:buNone/>
+            </a:pPr>
+            <a:r>
+              <a:rPr lang="en-US" dirty="0">
+                <a:solidFill>
+                  <a:srgbClr val="000000"/>
+                </a:solidFill>
+              </a:rPr>
+              <a:t>B</a:t>
+            </a:r>
+            <a:endParaRPr lang="en-US" dirty="0"/>
+          </a:p>
+        </p:txBody>
+      </p:sp>
+      <p:sp>
+        <p:nvSpPr>
+          <p:cNvPr id="10" name="Text 8"/>
+          <p:cNvSpPr/>
+          <p:nvPr>
+            <p:custDataLst>
+              <p:tags r:id="rId3"/>
+            </p:custDataLst>
+          </p:nvPr>
+        </p:nvSpPr>
+        <p:spPr>
+          <a:xfrm>
+            <a:off x="6138863" y="1019175"/>
+            <a:ext cx="581025" cy="581025"/>
+          </a:xfrm>
+          <a:prstGeom prst="ellipse">
+            <a:avLst/>
+          </a:prstGeom>
+          <a:solidFill>
+            <a:srgbClr val="DCDBCE"/>
+          </a:solidFill>
+          <a:ln w="9049">
+            <a:solidFill>
+              <a:srgbClr val="000000"/>
+            </a:solidFill>
+          </a:ln>
+        </p:spPr>
+        <p:txBody>
+          <a:bodyPr wrap="square" rtlCol="0" anchor="ctr"/>
+          <a:lstStyle/>
+          <a:p>
+            <a:pPr marL="0" indent="0">
+              <a:buNone/>
+            </a:pPr>
+            <a:r>
+              <a:rPr lang="en-US" dirty="0">
+                <a:solidFill>
+                  <a:srgbClr val="000000"/>
+                </a:solidFill>
+              </a:rPr>
+              <a:t>C</a:t>
+            </a:r>
+            <a:endParaRPr lang="en-US" dirty="0"/>
+          </a:p>
+        </p:txBody>
+      </p:sp>
+      <p:sp>
+        <p:nvSpPr>
+          <p:cNvPr id="11" name="Text 9"/>
+          <p:cNvSpPr/>
+          <p:nvPr>
+            <p:custDataLst>
+              <p:tags r:id="rId4"/>
+            </p:custDataLst>
+          </p:nvPr>
+        </p:nvSpPr>
+        <p:spPr>
+          <a:xfrm>
+            <a:off x="866775" y="1171575"/>
+            <a:ext cx="2290763" cy="276225"/>
+          </a:xfrm>
+          <a:prstGeom prst="rect">
+            <a:avLst/>
+          </a:prstGeom>
+          <a:noFill/>
+        </p:spPr>
+        <p:txBody>
+          <a:bodyPr wrap="square" lIns="0" tIns="0" rIns="0" bIns="0" rtlCol="0" anchor="ctr"/>
+          <a:lstStyle/>
+          <a:p>
+            <a:pPr marL="0" indent="0" algn="l">
+              <a:lnSpc>
+                <a:spcPts val="2060"/>
+              </a:lnSpc>
+              <a:buNone/>
+            </a:pPr>
+            <a:r>
+              <a:rPr lang="en-US" sz="1425" kern="0" spc="-28" dirty="0">
+                <a:solidFill>
+                  <a:srgbClr val="000000">
+                    <a:alpha val="99000"/>
+                  </a:srgbClr>
+                </a:solidFill>
+                <a:latin typeface="微软雅黑" panose="020B0503020204020204" charset="-122"/>
+                <a:ea typeface="微软雅黑" panose="020B0503020204020204" charset="-122"/>
+                <a:cs typeface="Work Sans" pitchFamily="34" charset="-120"/>
+              </a:rPr>
+              <a:t>Testing</a:t>
+            </a:r>
+            <a:endParaRPr lang="en-US" sz="1425" dirty="0">
+              <a:latin typeface="微软雅黑" panose="020B0503020204020204" charset="-122"/>
+              <a:ea typeface="微软雅黑" panose="020B0503020204020204" charset="-122"/>
+            </a:endParaRPr>
+          </a:p>
+        </p:txBody>
+      </p:sp>
+      <p:sp>
+        <p:nvSpPr>
+          <p:cNvPr id="12" name="Text 10"/>
+          <p:cNvSpPr/>
+          <p:nvPr>
+            <p:custDataLst>
+              <p:tags r:id="rId5"/>
+            </p:custDataLst>
+          </p:nvPr>
+        </p:nvSpPr>
+        <p:spPr>
+          <a:xfrm>
+            <a:off x="3848100" y="1171575"/>
+            <a:ext cx="2290763" cy="276225"/>
+          </a:xfrm>
+          <a:prstGeom prst="rect">
+            <a:avLst/>
+          </a:prstGeom>
+          <a:noFill/>
+        </p:spPr>
+        <p:txBody>
+          <a:bodyPr wrap="square" lIns="0" tIns="0" rIns="0" bIns="0" rtlCol="0" anchor="ctr"/>
+          <a:lstStyle/>
+          <a:p>
+            <a:pPr marL="0" indent="0" algn="l">
+              <a:lnSpc>
+                <a:spcPts val="2060"/>
+              </a:lnSpc>
+              <a:buNone/>
+            </a:pPr>
+            <a:r>
+              <a:rPr lang="en-US" sz="1425" kern="0" spc="-28" dirty="0">
+                <a:solidFill>
+                  <a:srgbClr val="000000">
+                    <a:alpha val="99000"/>
+                  </a:srgbClr>
+                </a:solidFill>
+                <a:latin typeface="微软雅黑" panose="020B0503020204020204" charset="-122"/>
+                <a:ea typeface="微软雅黑" panose="020B0503020204020204" charset="-122"/>
+                <a:cs typeface="Work Sans" pitchFamily="34" charset="-120"/>
+              </a:rPr>
+              <a:t>Deployment</a:t>
+            </a:r>
+            <a:endParaRPr lang="en-US" sz="1425" dirty="0">
+              <a:latin typeface="微软雅黑" panose="020B0503020204020204" charset="-122"/>
+              <a:ea typeface="微软雅黑" panose="020B0503020204020204" charset="-122"/>
+            </a:endParaRPr>
+          </a:p>
+        </p:txBody>
+      </p:sp>
+      <p:sp>
+        <p:nvSpPr>
+          <p:cNvPr id="13" name="Text 11"/>
+          <p:cNvSpPr/>
+          <p:nvPr>
+            <p:custDataLst>
+              <p:tags r:id="rId6"/>
+            </p:custDataLst>
+          </p:nvPr>
+        </p:nvSpPr>
+        <p:spPr>
+          <a:xfrm>
+            <a:off x="6829425" y="1171575"/>
+            <a:ext cx="2290763" cy="276225"/>
+          </a:xfrm>
+          <a:prstGeom prst="rect">
+            <a:avLst/>
+          </a:prstGeom>
+          <a:noFill/>
+        </p:spPr>
+        <p:txBody>
+          <a:bodyPr wrap="square" lIns="0" tIns="0" rIns="0" bIns="0" rtlCol="0" anchor="ctr"/>
+          <a:lstStyle/>
+          <a:p>
+            <a:pPr marL="0" indent="0" algn="l">
+              <a:lnSpc>
+                <a:spcPts val="2060"/>
+              </a:lnSpc>
+              <a:buNone/>
+            </a:pPr>
+            <a:r>
+              <a:rPr lang="en-US" sz="1425" kern="0" spc="-28" dirty="0">
+                <a:solidFill>
+                  <a:srgbClr val="000000">
+                    <a:alpha val="99000"/>
+                  </a:srgbClr>
+                </a:solidFill>
+                <a:latin typeface="微软雅黑" panose="020B0503020204020204" charset="-122"/>
+                <a:ea typeface="微软雅黑" panose="020B0503020204020204" charset="-122"/>
+                <a:cs typeface="Work Sans" pitchFamily="34" charset="-120"/>
+              </a:rPr>
+              <a:t>Deliverables</a:t>
+            </a:r>
+            <a:endParaRPr lang="en-US" sz="1425" dirty="0">
+              <a:latin typeface="微软雅黑" panose="020B0503020204020204" charset="-122"/>
+              <a:ea typeface="微软雅黑" panose="020B0503020204020204" charset="-122"/>
+            </a:endParaRPr>
+          </a:p>
+        </p:txBody>
+      </p:sp>
+      <p:sp>
+        <p:nvSpPr>
+          <p:cNvPr id="14" name="Text 12"/>
+          <p:cNvSpPr/>
+          <p:nvPr>
+            <p:custDataLst>
+              <p:tags r:id="rId7"/>
+            </p:custDataLst>
+          </p:nvPr>
+        </p:nvSpPr>
+        <p:spPr>
+          <a:xfrm>
+            <a:off x="85725" y="1828483"/>
+            <a:ext cx="2667000" cy="1104900"/>
+          </a:xfrm>
+          <a:prstGeom prst="rect">
+            <a:avLst/>
+          </a:prstGeom>
+          <a:noFill/>
+        </p:spPr>
+        <p:txBody>
+          <a:bodyPr wrap="square" lIns="0" tIns="0" rIns="0" bIns="0" rtlCol="0" anchor="ctr"/>
+          <a:lstStyle/>
+          <a:p>
+            <a:pPr marL="342900" indent="-342900" algn="l">
+              <a:lnSpc>
+                <a:spcPts val="2060"/>
+              </a:lnSpc>
+              <a:buSzPct val="100000"/>
+              <a:buChar char="•"/>
+            </a:pPr>
+            <a:r>
+              <a:rPr lang="en-US" sz="855" kern="0" spc="-17" dirty="0">
+                <a:solidFill>
+                  <a:srgbClr val="000000">
+                    <a:alpha val="99000"/>
+                  </a:srgbClr>
+                </a:solidFill>
+                <a:latin typeface="微软雅黑" panose="020B0503020204020204" charset="-122"/>
+                <a:ea typeface="微软雅黑" panose="020B0503020204020204" charset="-122"/>
+                <a:cs typeface="Work Sans" pitchFamily="34" charset="-120"/>
+              </a:rPr>
+              <a:t>Endpoint tests with pytest</a:t>
+            </a:r>
+            <a:endParaRPr lang="en-US" sz="855" dirty="0">
+              <a:latin typeface="微软雅黑" panose="020B0503020204020204" charset="-122"/>
+              <a:ea typeface="微软雅黑" panose="020B0503020204020204" charset="-122"/>
+            </a:endParaRPr>
+          </a:p>
+          <a:p>
+            <a:pPr marL="342900" indent="-342900" algn="l">
+              <a:lnSpc>
+                <a:spcPts val="2060"/>
+              </a:lnSpc>
+              <a:buSzPct val="100000"/>
+              <a:buChar char="•"/>
+            </a:pPr>
+            <a:r>
+              <a:rPr lang="en-US" sz="855" kern="0" spc="-17" dirty="0">
+                <a:solidFill>
+                  <a:srgbClr val="000000">
+                    <a:alpha val="99000"/>
+                  </a:srgbClr>
+                </a:solidFill>
+                <a:latin typeface="微软雅黑" panose="020B0503020204020204" charset="-122"/>
+                <a:ea typeface="微软雅黑" panose="020B0503020204020204" charset="-122"/>
+                <a:cs typeface="Work Sans" pitchFamily="34" charset="-120"/>
+              </a:rPr>
+              <a:t>Validation of success and error cases</a:t>
+            </a:r>
+            <a:endParaRPr lang="en-US" sz="855" dirty="0">
+              <a:latin typeface="微软雅黑" panose="020B0503020204020204" charset="-122"/>
+              <a:ea typeface="微软雅黑" panose="020B0503020204020204" charset="-122"/>
+            </a:endParaRPr>
+          </a:p>
+          <a:p>
+            <a:pPr marL="342900" indent="-342900" algn="l">
+              <a:lnSpc>
+                <a:spcPts val="2060"/>
+              </a:lnSpc>
+              <a:buSzPct val="100000"/>
+              <a:buChar char="•"/>
+            </a:pPr>
+            <a:r>
+              <a:rPr lang="en-US" sz="855" kern="0" spc="-17" dirty="0">
+                <a:solidFill>
+                  <a:srgbClr val="000000">
+                    <a:alpha val="99000"/>
+                  </a:srgbClr>
+                </a:solidFill>
+                <a:latin typeface="微软雅黑" panose="020B0503020204020204" charset="-122"/>
+                <a:ea typeface="微软雅黑" panose="020B0503020204020204" charset="-122"/>
+                <a:cs typeface="Work Sans" pitchFamily="34" charset="-120"/>
+              </a:rPr>
+              <a:t>Coverage of query parameters and edge cases</a:t>
+            </a:r>
+            <a:endParaRPr lang="en-US" sz="855" dirty="0">
+              <a:latin typeface="微软雅黑" panose="020B0503020204020204" charset="-122"/>
+              <a:ea typeface="微软雅黑" panose="020B0503020204020204" charset="-122"/>
+            </a:endParaRPr>
+          </a:p>
+          <a:p>
+            <a:pPr marL="342900" indent="-342900" algn="l">
+              <a:lnSpc>
+                <a:spcPts val="2060"/>
+              </a:lnSpc>
+              <a:buSzPct val="100000"/>
+              <a:buChar char="•"/>
+            </a:pPr>
+            <a:r>
+              <a:rPr lang="en-US" sz="855" kern="0" spc="-17" dirty="0">
+                <a:solidFill>
+                  <a:srgbClr val="000000">
+                    <a:alpha val="99000"/>
+                  </a:srgbClr>
+                </a:solidFill>
+                <a:latin typeface="微软雅黑" panose="020B0503020204020204" charset="-122"/>
+                <a:ea typeface="微软雅黑" panose="020B0503020204020204" charset="-122"/>
+                <a:cs typeface="Work Sans" pitchFamily="34" charset="-120"/>
+              </a:rPr>
+              <a:t>Verified expected status codes and responses</a:t>
+            </a:r>
+            <a:endParaRPr lang="en-US" sz="855" dirty="0">
+              <a:latin typeface="微软雅黑" panose="020B0503020204020204" charset="-122"/>
+              <a:ea typeface="微软雅黑" panose="020B0503020204020204" charset="-122"/>
+            </a:endParaRPr>
+          </a:p>
+        </p:txBody>
+      </p:sp>
+      <p:sp>
+        <p:nvSpPr>
+          <p:cNvPr id="15" name="Text 13"/>
+          <p:cNvSpPr/>
+          <p:nvPr>
+            <p:custDataLst>
+              <p:tags r:id="rId8"/>
+            </p:custDataLst>
+          </p:nvPr>
+        </p:nvSpPr>
+        <p:spPr>
+          <a:xfrm>
+            <a:off x="6138863" y="1614488"/>
+            <a:ext cx="2667000" cy="1376363"/>
+          </a:xfrm>
+          <a:prstGeom prst="rect">
+            <a:avLst/>
+          </a:prstGeom>
+          <a:noFill/>
+        </p:spPr>
+        <p:txBody>
+          <a:bodyPr wrap="square" lIns="0" tIns="0" rIns="0" bIns="0" rtlCol="0" anchor="ctr"/>
+          <a:lstStyle/>
+          <a:p>
+            <a:pPr marL="342900" indent="-342900" algn="l">
+              <a:lnSpc>
+                <a:spcPts val="2060"/>
+              </a:lnSpc>
+              <a:buSzPct val="100000"/>
+              <a:buChar char="•"/>
+            </a:pPr>
+            <a:r>
+              <a:rPr lang="en-US" sz="855" kern="0" spc="-17" dirty="0">
+                <a:solidFill>
+                  <a:srgbClr val="000000">
+                    <a:alpha val="99000"/>
+                  </a:srgbClr>
+                </a:solidFill>
+                <a:latin typeface="微软雅黑" panose="020B0503020204020204" charset="-122"/>
+                <a:ea typeface="微软雅黑" panose="020B0503020204020204" charset="-122"/>
+                <a:cs typeface="Work Sans" pitchFamily="34" charset="-120"/>
+              </a:rPr>
+              <a:t>Public GitHub repository with commit history</a:t>
+            </a:r>
+            <a:endParaRPr lang="en-US" sz="855" dirty="0">
+              <a:latin typeface="微软雅黑" panose="020B0503020204020204" charset="-122"/>
+              <a:ea typeface="微软雅黑" panose="020B0503020204020204" charset="-122"/>
+            </a:endParaRPr>
+          </a:p>
+          <a:p>
+            <a:pPr marL="342900" indent="-342900" algn="l">
+              <a:lnSpc>
+                <a:spcPts val="2060"/>
+              </a:lnSpc>
+              <a:buSzPct val="100000"/>
+              <a:buChar char="•"/>
+            </a:pPr>
+            <a:r>
+              <a:rPr lang="en-US" sz="855" kern="0" spc="-17" dirty="0">
+                <a:solidFill>
+                  <a:srgbClr val="000000">
+                    <a:alpha val="99000"/>
+                  </a:srgbClr>
+                </a:solidFill>
+                <a:latin typeface="微软雅黑" panose="020B0503020204020204" charset="-122"/>
+                <a:ea typeface="微软雅黑" panose="020B0503020204020204" charset="-122"/>
+                <a:cs typeface="Work Sans" pitchFamily="34" charset="-120"/>
+              </a:rPr>
+              <a:t>API documentation and technical report</a:t>
+            </a:r>
+            <a:endParaRPr lang="en-US" sz="855" dirty="0">
+              <a:latin typeface="微软雅黑" panose="020B0503020204020204" charset="-122"/>
+              <a:ea typeface="微软雅黑" panose="020B0503020204020204" charset="-122"/>
+            </a:endParaRPr>
+          </a:p>
+          <a:p>
+            <a:pPr marL="342900" indent="-342900" algn="l">
+              <a:lnSpc>
+                <a:spcPts val="2060"/>
+              </a:lnSpc>
+              <a:buSzPct val="100000"/>
+              <a:buChar char="•"/>
+            </a:pPr>
+            <a:r>
+              <a:rPr lang="en-US" sz="855" kern="0" spc="-17" dirty="0">
+                <a:solidFill>
+                  <a:srgbClr val="000000">
+                    <a:alpha val="99000"/>
+                  </a:srgbClr>
+                </a:solidFill>
+                <a:latin typeface="微软雅黑" panose="020B0503020204020204" charset="-122"/>
+                <a:ea typeface="微软雅黑" panose="020B0503020204020204" charset="-122"/>
+                <a:cs typeface="Work Sans" pitchFamily="34" charset="-120"/>
+              </a:rPr>
+              <a:t>Source code, database setup, and evidence of development</a:t>
+            </a:r>
+            <a:endParaRPr lang="en-US" sz="855" dirty="0">
+              <a:latin typeface="微软雅黑" panose="020B0503020204020204" charset="-122"/>
+              <a:ea typeface="微软雅黑" panose="020B0503020204020204" charset="-122"/>
+            </a:endParaRPr>
+          </a:p>
+          <a:p>
+            <a:pPr marL="342900" indent="-342900" algn="l">
+              <a:lnSpc>
+                <a:spcPts val="2060"/>
+              </a:lnSpc>
+              <a:buSzPct val="100000"/>
+              <a:buChar char="•"/>
+            </a:pPr>
+            <a:r>
+              <a:rPr lang="en-US" sz="855" kern="0" spc="-17" dirty="0">
+                <a:solidFill>
+                  <a:srgbClr val="000000">
+                    <a:alpha val="99000"/>
+                  </a:srgbClr>
+                </a:solidFill>
+                <a:latin typeface="微软雅黑" panose="020B0503020204020204" charset="-122"/>
+                <a:ea typeface="微软雅黑" panose="020B0503020204020204" charset="-122"/>
+                <a:cs typeface="Work Sans" pitchFamily="34" charset="-120"/>
+              </a:rPr>
+              <a:t>Presentation and submission-ready materials</a:t>
+            </a:r>
+            <a:endParaRPr lang="en-US" sz="855" dirty="0">
+              <a:latin typeface="微软雅黑" panose="020B0503020204020204" charset="-122"/>
+              <a:ea typeface="微软雅黑" panose="020B0503020204020204" charset="-122"/>
+            </a:endParaRPr>
+          </a:p>
+        </p:txBody>
+      </p:sp>
+      <p:sp>
+        <p:nvSpPr>
+          <p:cNvPr id="16" name="Text 14"/>
+          <p:cNvSpPr/>
+          <p:nvPr>
+            <p:custDataLst>
+              <p:tags r:id="rId9"/>
+            </p:custDataLst>
+          </p:nvPr>
+        </p:nvSpPr>
+        <p:spPr>
+          <a:xfrm>
+            <a:off x="3157538" y="1614488"/>
+            <a:ext cx="2662238" cy="1104900"/>
+          </a:xfrm>
+          <a:prstGeom prst="rect">
+            <a:avLst/>
+          </a:prstGeom>
+          <a:noFill/>
+        </p:spPr>
+        <p:txBody>
+          <a:bodyPr wrap="square" lIns="0" tIns="0" rIns="0" bIns="0" rtlCol="0" anchor="ctr"/>
+          <a:lstStyle/>
+          <a:p>
+            <a:pPr marL="342900" indent="-342900" algn="l">
+              <a:lnSpc>
+                <a:spcPts val="2060"/>
+              </a:lnSpc>
+              <a:buSzPct val="100000"/>
+              <a:buChar char="•"/>
+            </a:pPr>
+            <a:r>
+              <a:rPr lang="en-US" sz="855" kern="0" spc="-17" dirty="0">
+                <a:solidFill>
+                  <a:srgbClr val="000000">
+                    <a:alpha val="99000"/>
+                  </a:srgbClr>
+                </a:solidFill>
+                <a:latin typeface="微软雅黑" panose="020B0503020204020204" charset="-122"/>
+                <a:ea typeface="微软雅黑" panose="020B0503020204020204" charset="-122"/>
+                <a:cs typeface="Work Sans" pitchFamily="34" charset="-120"/>
+              </a:rPr>
+              <a:t>Deployed as a runnable web service</a:t>
+            </a:r>
+            <a:endParaRPr lang="en-US" sz="855" dirty="0">
+              <a:latin typeface="微软雅黑" panose="020B0503020204020204" charset="-122"/>
+              <a:ea typeface="微软雅黑" panose="020B0503020204020204" charset="-122"/>
+            </a:endParaRPr>
+          </a:p>
+          <a:p>
+            <a:pPr marL="342900" indent="-342900" algn="l">
+              <a:lnSpc>
+                <a:spcPts val="2060"/>
+              </a:lnSpc>
+              <a:buSzPct val="100000"/>
+              <a:buChar char="•"/>
+            </a:pPr>
+            <a:r>
+              <a:rPr lang="en-US" sz="855" kern="0" spc="-17" dirty="0">
+                <a:solidFill>
+                  <a:srgbClr val="000000">
+                    <a:alpha val="99000"/>
+                  </a:srgbClr>
+                </a:solidFill>
+                <a:latin typeface="微软雅黑" panose="020B0503020204020204" charset="-122"/>
+                <a:ea typeface="微软雅黑" panose="020B0503020204020204" charset="-122"/>
+                <a:cs typeface="Work Sans" pitchFamily="34" charset="-120"/>
+              </a:rPr>
+              <a:t>Interactive API documentation available</a:t>
+            </a:r>
+            <a:endParaRPr lang="en-US" sz="855" dirty="0">
+              <a:latin typeface="微软雅黑" panose="020B0503020204020204" charset="-122"/>
+              <a:ea typeface="微软雅黑" panose="020B0503020204020204" charset="-122"/>
+            </a:endParaRPr>
+          </a:p>
+          <a:p>
+            <a:pPr marL="342900" indent="-342900" algn="l">
+              <a:lnSpc>
+                <a:spcPts val="2060"/>
+              </a:lnSpc>
+              <a:buSzPct val="100000"/>
+              <a:buChar char="•"/>
+            </a:pPr>
+            <a:r>
+              <a:rPr lang="en-US" sz="855" kern="0" spc="-17" dirty="0">
+                <a:solidFill>
+                  <a:srgbClr val="000000">
+                    <a:alpha val="99000"/>
+                  </a:srgbClr>
+                </a:solidFill>
+                <a:latin typeface="微软雅黑" panose="020B0503020204020204" charset="-122"/>
+                <a:ea typeface="微软雅黑" panose="020B0503020204020204" charset="-122"/>
+                <a:cs typeface="Work Sans" pitchFamily="34" charset="-120"/>
+              </a:rPr>
+              <a:t>Submission version aligned with hosted demo</a:t>
+            </a:r>
+            <a:endParaRPr lang="en-US" sz="855" dirty="0">
+              <a:latin typeface="微软雅黑" panose="020B0503020204020204" charset="-122"/>
+              <a:ea typeface="微软雅黑" panose="020B0503020204020204" charset="-122"/>
+            </a:endParaRPr>
+          </a:p>
+          <a:p>
+            <a:pPr marL="342900" indent="-342900" algn="l">
+              <a:lnSpc>
+                <a:spcPts val="2060"/>
+              </a:lnSpc>
+              <a:buSzPct val="100000"/>
+              <a:buChar char="•"/>
+            </a:pPr>
+            <a:r>
+              <a:rPr lang="en-US" sz="855" kern="0" spc="-17" dirty="0">
+                <a:solidFill>
+                  <a:srgbClr val="000000">
+                    <a:alpha val="99000"/>
+                  </a:srgbClr>
+                </a:solidFill>
+                <a:latin typeface="微软雅黑" panose="020B0503020204020204" charset="-122"/>
+                <a:ea typeface="微软雅黑" panose="020B0503020204020204" charset="-122"/>
+                <a:cs typeface="Work Sans" pitchFamily="34" charset="-120"/>
+              </a:rPr>
+              <a:t>CI/CD used for deployment validation</a:t>
+            </a:r>
+            <a:endParaRPr lang="en-US" sz="855" dirty="0">
+              <a:latin typeface="微软雅黑" panose="020B0503020204020204" charset="-122"/>
+              <a:ea typeface="微软雅黑" panose="020B0503020204020204" charset="-122"/>
+            </a:endParaRPr>
           </a:p>
         </p:txBody>
       </p:sp>
       <p:pic>
         <p:nvPicPr>
-          <p:cNvPr id="23" name="图片 22"/>
+          <p:cNvPr id="17" name="Image 0" descr="preencoded.png"/>
           <p:cNvPicPr>
             <a:picLocks noChangeAspect="1"/>
           </p:cNvPicPr>
           <p:nvPr/>
         </p:nvPicPr>
         <p:blipFill>
-          <a:blip r:embed="rId1"/>
+          <a:blip r:embed="rId10"/>
+          <a:srcRect/>
           <a:stretch>
             <a:fillRect/>
           </a:stretch>
         </p:blipFill>
         <p:spPr>
           <a:xfrm>
-            <a:off x="115570" y="1971675"/>
-            <a:ext cx="2999740" cy="2729865"/>
+            <a:off x="190500" y="3333750"/>
+            <a:ext cx="2085975" cy="1185863"/>
           </a:xfrm>
           <a:prstGeom prst="rect">
             <a:avLst/>
@@ -9324,22 +9688,102 @@
       </p:pic>
       <p:pic>
         <p:nvPicPr>
-          <p:cNvPr id="25" name="图片 24"/>
+          <p:cNvPr id="18" name="Image 1" descr="preencoded.png"/>
           <p:cNvPicPr>
             <a:picLocks noChangeAspect="1"/>
           </p:cNvPicPr>
-          <p:nvPr/>
+          <p:nvPr>
+            <p:custDataLst>
+              <p:tags r:id="rId11"/>
+            </p:custDataLst>
+          </p:nvPr>
         </p:nvPicPr>
         <p:blipFill>
-          <a:blip r:embed="rId2"/>
+          <a:blip r:embed="rId12"/>
+          <a:srcRect/>
           <a:stretch>
             <a:fillRect/>
           </a:stretch>
         </p:blipFill>
         <p:spPr>
           <a:xfrm>
-            <a:off x="3700780" y="1971675"/>
-            <a:ext cx="3445510" cy="2173605"/>
+            <a:off x="3305175" y="2866708"/>
+            <a:ext cx="2366963" cy="514350"/>
+          </a:xfrm>
+          <a:prstGeom prst="rect">
+            <a:avLst/>
+          </a:prstGeom>
+        </p:spPr>
+      </p:pic>
+      <p:pic>
+        <p:nvPicPr>
+          <p:cNvPr id="19" name="Image 2" descr="preencoded.png"/>
+          <p:cNvPicPr>
+            <a:picLocks noChangeAspect="1"/>
+          </p:cNvPicPr>
+          <p:nvPr/>
+        </p:nvPicPr>
+        <p:blipFill>
+          <a:blip r:embed="rId13"/>
+          <a:srcRect/>
+          <a:stretch>
+            <a:fillRect/>
+          </a:stretch>
+        </p:blipFill>
+        <p:spPr>
+          <a:xfrm>
+            <a:off x="3243263" y="3529013"/>
+            <a:ext cx="2547938" cy="885825"/>
+          </a:xfrm>
+          <a:prstGeom prst="rect">
+            <a:avLst/>
+          </a:prstGeom>
+        </p:spPr>
+      </p:pic>
+      <p:pic>
+        <p:nvPicPr>
+          <p:cNvPr id="20" name="Image 3" descr="preencoded.png"/>
+          <p:cNvPicPr>
+            <a:picLocks noChangeAspect="1"/>
+          </p:cNvPicPr>
+          <p:nvPr/>
+        </p:nvPicPr>
+        <p:blipFill>
+          <a:blip r:embed="rId14"/>
+          <a:srcRect/>
+          <a:stretch>
+            <a:fillRect/>
+          </a:stretch>
+        </p:blipFill>
+        <p:spPr>
+          <a:xfrm>
+            <a:off x="6138863" y="2990850"/>
+            <a:ext cx="1162050" cy="1133475"/>
+          </a:xfrm>
+          <a:prstGeom prst="rect">
+            <a:avLst/>
+          </a:prstGeom>
+        </p:spPr>
+      </p:pic>
+      <p:pic>
+        <p:nvPicPr>
+          <p:cNvPr id="21" name="Image 4" descr="preencoded.png"/>
+          <p:cNvPicPr>
+            <a:picLocks noChangeAspect="1"/>
+          </p:cNvPicPr>
+          <p:nvPr/>
+        </p:nvPicPr>
+        <p:blipFill>
+          <a:blip r:embed="rId15"/>
+          <a:srcRect/>
+          <a:stretch>
+            <a:fillRect/>
+          </a:stretch>
+        </p:blipFill>
+        <p:spPr>
+          <a:xfrm>
+            <a:off x="7472363" y="2990850"/>
+            <a:ext cx="1085850" cy="1528763"/>
           </a:xfrm>
           <a:prstGeom prst="rect">
             <a:avLst/>

</xml_diff>